<commit_message>
Make exec summary section headers punchy assertion sentences
Replace the one-word quadrant labels (problem/why now/plan/return) with
short message headlines: fragmentation is taxing growth and capital;
waiting gets more expensive every quarter; one plan: experience first,
then back-ends; simplification funds the shift to growth.

Co-Authored-By: Claude Fable 5 <noreply@anthropic.com>
Claude-Session: https://claude.ai/code/session_01EWFJ2qXeCLrhhc9JV2HxT2
</commit_message>
<xml_diff>
--- a/TAM_2.0_Tech_Committee_2pager.pptx
+++ b/TAM_2.0_Tech_Committee_2pager.pptx
@@ -1087,7 +1087,7 @@
         <p:spPr>
           <a:xfrm>
             <a:off x="777240" y="1097280"/>
-            <a:ext cx="3657600" cy="274320"/>
+            <a:ext cx="4929988" cy="274320"/>
           </a:xfrm>
           <a:prstGeom prst="rect">
             <a:avLst/>
@@ -1103,7 +1103,7 @@
               <a:buNone/>
             </a:pPr>
             <a:r>
-              <a:rPr lang="en-US" sz="1100" b="1" spc="300" kern="0" dirty="0">
+              <a:rPr lang="en-US" sz="1100" b="1" spc="200" kern="0" dirty="0">
                 <a:solidFill>
                   <a:srgbClr val="262AFF"/>
                 </a:solidFill>
@@ -1111,7 +1111,7 @@
                 <a:ea typeface="DM Sans" pitchFamily="34" charset="-122"/>
                 <a:cs typeface="DM Sans" pitchFamily="34" charset="-120"/>
               </a:rPr>
-              <a:t>THE PROBLEM</a:t>
+              <a:t>FRAGMENTATION IS TAXING GROWTH AND CAPITAL</a:t>
             </a:r>
             <a:endParaRPr lang="en-US" sz="1100" dirty="0"/>
           </a:p>
@@ -1550,7 +1550,7 @@
         <p:spPr>
           <a:xfrm>
             <a:off x="6484468" y="1097280"/>
-            <a:ext cx="3657600" cy="274320"/>
+            <a:ext cx="4929988" cy="274320"/>
           </a:xfrm>
           <a:prstGeom prst="rect">
             <a:avLst/>
@@ -1566,7 +1566,7 @@
               <a:buNone/>
             </a:pPr>
             <a:r>
-              <a:rPr lang="en-US" sz="1100" b="1" spc="300" kern="0" dirty="0">
+              <a:rPr lang="en-US" sz="1100" b="1" spc="200" kern="0" dirty="0">
                 <a:solidFill>
                   <a:srgbClr val="262AFF"/>
                 </a:solidFill>
@@ -1574,7 +1574,7 @@
                 <a:ea typeface="DM Sans" pitchFamily="34" charset="-122"/>
                 <a:cs typeface="DM Sans" pitchFamily="34" charset="-120"/>
               </a:rPr>
-              <a:t>WHY NOW</a:t>
+              <a:t>WAITING GETS MORE EXPENSIVE EVERY QUARTER</a:t>
             </a:r>
             <a:endParaRPr lang="en-US" sz="1100" dirty="0"/>
           </a:p>
@@ -1902,7 +1902,7 @@
         <p:spPr>
           <a:xfrm>
             <a:off x="777240" y="3639312"/>
-            <a:ext cx="3657600" cy="274320"/>
+            <a:ext cx="4929988" cy="274320"/>
           </a:xfrm>
           <a:prstGeom prst="rect">
             <a:avLst/>
@@ -1918,7 +1918,7 @@
               <a:buNone/>
             </a:pPr>
             <a:r>
-              <a:rPr lang="en-US" sz="1100" b="1" spc="300" kern="0" dirty="0">
+              <a:rPr lang="en-US" sz="1100" b="1" spc="200" kern="0" dirty="0">
                 <a:solidFill>
                   <a:srgbClr val="262AFF"/>
                 </a:solidFill>
@@ -1926,7 +1926,7 @@
                 <a:ea typeface="DM Sans" pitchFamily="34" charset="-122"/>
                 <a:cs typeface="DM Sans" pitchFamily="34" charset="-120"/>
               </a:rPr>
-              <a:t>THE PLAN</a:t>
+              <a:t>ONE PLAN: EXPERIENCE FIRST, THEN BACK-ENDS</a:t>
             </a:r>
             <a:endParaRPr lang="en-US" sz="1100" dirty="0"/>
           </a:p>
@@ -2329,7 +2329,7 @@
         <p:spPr>
           <a:xfrm>
             <a:off x="6484468" y="3639312"/>
-            <a:ext cx="3657600" cy="274320"/>
+            <a:ext cx="4929988" cy="274320"/>
           </a:xfrm>
           <a:prstGeom prst="rect">
             <a:avLst/>
@@ -2345,7 +2345,7 @@
               <a:buNone/>
             </a:pPr>
             <a:r>
-              <a:rPr lang="en-US" sz="1100" b="1" spc="300" kern="0" dirty="0">
+              <a:rPr lang="en-US" sz="1100" b="1" spc="200" kern="0" dirty="0">
                 <a:solidFill>
                   <a:srgbClr val="262AFF"/>
                 </a:solidFill>
@@ -2353,7 +2353,7 @@
                 <a:ea typeface="DM Sans" pitchFamily="34" charset="-122"/>
                 <a:cs typeface="DM Sans" pitchFamily="34" charset="-120"/>
               </a:rPr>
-              <a:t>THE RETURN</a:t>
+              <a:t>SIMPLIFICATION FUNDS THE SHIFT TO GROWTH</a:t>
             </a:r>
             <a:endParaRPr lang="en-US" sz="1100" dirty="0"/>
           </a:p>
@@ -5337,7 +5337,7 @@
               <a:buNone/>
             </a:pPr>
             <a:r>
-              <a:rPr lang="en-US" sz="1100" b="1" spc="300" kern="0" dirty="0">
+              <a:rPr lang="en-US" sz="1100" b="1" spc="200" kern="0" dirty="0">
                 <a:solidFill>
                   <a:srgbClr val="262AFF"/>
                 </a:solidFill>

</xml_diff>

<commit_message>
Restructure exec summary to 3x2 grid; drop 10%->8% claim
Top row adds a "what we did" box (GP25 & Helix track record, target
state decided); bottom row adds a "what's next" box (sequencing, cost
to achieve, execution-ready plan back to Tech Committee & Board).
Removed the ~10%->~8% tech-spend projection from both pages; the
from-to rail now shows >80% / $200M+ / KTLO->growth.

Co-Authored-By: Claude Fable 5 <noreply@anthropic.com>
Claude-Session: https://claude.ai/code/session_01EWFJ2qXeCLrhhc9JV2HxT2
</commit_message>
<xml_diff>
--- a/TAM_2.0_Tech_Committee_2pager.pptx
+++ b/TAM_2.0_Tech_Committee_2pager.pptx
@@ -503,7 +503,7 @@
           <a:p>
             <a:r>
               <a:rPr lang="en-US" dirty="0"/>
-              <a:t>One-page executive summary of the July 2026 TAM 2.0 Board update, prepared for the Technology Committee. Reads in four blocks: the problem (fragmented estate, capex locked in KTLO), why now (customer expectations, perception gap, synergy commitments), the plan (&gt;80% estate reduction in two phases, ~$500M front-loaded), and the return ($200M+ committed opex unlock, tech spend from ~10% to ~8% of revenue, growth via enter/win/retain).</a:t>
+              <a:t>One-page executive summary of the July 2026 TAM 2.0 Board update, prepared for the Technology Committee. Reads as a 3x2 grid: the problem (fragmented estate, capex locked in KTLO), why now (customer expectations, perception gap, synergy commitments), what we did (GP25 &amp; Helix results, target state decided), the plan (&gt;80% estate reduction in two phases), the return ($200M+ committed opex unlock; enter/win/retain), and what's next (sequencing, cost to achieve, execution-ready plan back to Technology Committee &amp; Board).</a:t>
             </a:r>
             <a:endParaRPr lang="en-US" dirty="0"/>
           </a:p>
@@ -591,7 +591,7 @@
           <a:p>
             <a:r>
               <a:rPr lang="en-US" dirty="0"/>
-              <a:t>From-to view of the TAM 2.0 target state, drawn from the consolidation-impact pages of the July 2026 Board update. Left: platform counts by capability, today versus target. Right: what the consolidation unlocks — &gt;80% smaller estate, tech spend moving from ~10% to ~8% of revenue, and the committed $200M+ opex unlock.</a:t>
+              <a:t>From-to view of the TAM 2.0 target state, drawn from the consolidation-impact pages of the July 2026 Board update. Left: platform counts by capability, today versus target. Right: what the consolidation unlocks — &gt;80% smaller estate, the committed $200M+ opex unlock, and capital refocused from KTLO to strategic development.</a:t>
             </a:r>
             <a:endParaRPr lang="en-US" dirty="0"/>
           </a:p>
@@ -1065,7 +1065,7 @@
         <p:spPr>
           <a:xfrm>
             <a:off x="502920" y="914400"/>
-            <a:ext cx="5478628" cy="2331720"/>
+            <a:ext cx="3594506" cy="2331720"/>
           </a:xfrm>
           <a:prstGeom prst="roundRect">
             <a:avLst>
@@ -1086,8 +1086,8 @@
         </p:nvSpPr>
         <p:spPr>
           <a:xfrm>
-            <a:off x="777240" y="1097280"/>
-            <a:ext cx="4929988" cy="274320"/>
+            <a:off x="722376" y="1078992"/>
+            <a:ext cx="3155594" cy="256032"/>
           </a:xfrm>
           <a:prstGeom prst="rect">
             <a:avLst/>
@@ -1103,7 +1103,7 @@
               <a:buNone/>
             </a:pPr>
             <a:r>
-              <a:rPr lang="en-US" sz="1100" b="1" spc="200" kern="0" dirty="0">
+              <a:rPr lang="en-US" sz="1050" b="1" spc="200" kern="0" dirty="0">
                 <a:solidFill>
                   <a:srgbClr val="262AFF"/>
                 </a:solidFill>
@@ -1111,9 +1111,9 @@
                 <a:ea typeface="DM Sans" pitchFamily="34" charset="-122"/>
                 <a:cs typeface="DM Sans" pitchFamily="34" charset="-120"/>
               </a:rPr>
-              <a:t>FRAGMENTATION IS TAXING GROWTH AND CAPITAL</a:t>
-            </a:r>
-            <a:endParaRPr lang="en-US" sz="1100" dirty="0"/>
+              <a:t>FRAGMENTATION IS TAXING GROWTH</a:t>
+            </a:r>
+            <a:endParaRPr lang="en-US" sz="1050" dirty="0"/>
           </a:p>
         </p:txBody>
       </p:sp>
@@ -1125,24 +1125,24 @@
         </p:nvSpPr>
         <p:spPr>
           <a:xfrm>
-            <a:off x="777240" y="1481328"/>
-            <a:ext cx="2468880" cy="457200"/>
-          </a:xfrm>
-          <a:prstGeom prst="rect">
-            <a:avLst/>
-          </a:prstGeom>
-          <a:noFill/>
-          <a:ln/>
-        </p:spPr>
-        <p:txBody>
-          <a:bodyPr wrap="square" lIns="0" tIns="0" rIns="0" bIns="0" rtlCol="0" anchor="ctr"/>
-          <a:lstStyle/>
-          <a:p>
-            <a:pPr indent="0" marL="0">
-              <a:buNone/>
-            </a:pPr>
-            <a:r>
-              <a:rPr lang="en-US" sz="3000" b="1" dirty="0">
+            <a:off x="722376" y="1417320"/>
+            <a:ext cx="1536192" cy="365760"/>
+          </a:xfrm>
+          <a:prstGeom prst="rect">
+            <a:avLst/>
+          </a:prstGeom>
+          <a:noFill/>
+          <a:ln/>
+        </p:spPr>
+        <p:txBody>
+          <a:bodyPr wrap="square" lIns="0" tIns="0" rIns="0" bIns="0" rtlCol="0" anchor="ctr"/>
+          <a:lstStyle/>
+          <a:p>
+            <a:pPr indent="0" marL="0">
+              <a:buNone/>
+            </a:pPr>
+            <a:r>
+              <a:rPr lang="en-US" sz="2200" b="1" dirty="0">
                 <a:solidFill>
                   <a:srgbClr val="0C0C0C"/>
                 </a:solidFill>
@@ -1152,7 +1152,7 @@
               </a:rPr>
               <a:t>100s</a:t>
             </a:r>
-            <a:endParaRPr lang="en-US" sz="3000" dirty="0"/>
+            <a:endParaRPr lang="en-US" sz="2200" dirty="0"/>
           </a:p>
         </p:txBody>
       </p:sp>
@@ -1164,24 +1164,24 @@
         </p:nvSpPr>
         <p:spPr>
           <a:xfrm>
-            <a:off x="777240" y="1911096"/>
-            <a:ext cx="2468880" cy="228600"/>
-          </a:xfrm>
-          <a:prstGeom prst="rect">
-            <a:avLst/>
-          </a:prstGeom>
-          <a:noFill/>
-          <a:ln/>
-        </p:spPr>
-        <p:txBody>
-          <a:bodyPr wrap="square" lIns="0" tIns="0" rIns="0" bIns="0" rtlCol="0" anchor="ctr"/>
-          <a:lstStyle/>
-          <a:p>
-            <a:pPr indent="0" marL="0">
-              <a:buNone/>
-            </a:pPr>
-            <a:r>
-              <a:rPr lang="en-US" sz="1050" dirty="0">
+            <a:off x="722376" y="1764792"/>
+            <a:ext cx="1536192" cy="201168"/>
+          </a:xfrm>
+          <a:prstGeom prst="rect">
+            <a:avLst/>
+          </a:prstGeom>
+          <a:noFill/>
+          <a:ln/>
+        </p:spPr>
+        <p:txBody>
+          <a:bodyPr wrap="square" lIns="0" tIns="0" rIns="0" bIns="0" rtlCol="0" anchor="ctr"/>
+          <a:lstStyle/>
+          <a:p>
+            <a:pPr indent="0" marL="0">
+              <a:buNone/>
+            </a:pPr>
+            <a:r>
+              <a:rPr lang="en-US" sz="900" dirty="0">
                 <a:solidFill>
                   <a:srgbClr val="55565B"/>
                 </a:solidFill>
@@ -1191,7 +1191,7 @@
               </a:rPr>
               <a:t>overlapping platforms</a:t>
             </a:r>
-            <a:endParaRPr lang="en-US" sz="1050" dirty="0"/>
+            <a:endParaRPr lang="en-US" sz="900" dirty="0"/>
           </a:p>
         </p:txBody>
       </p:sp>
@@ -1203,24 +1203,24 @@
         </p:nvSpPr>
         <p:spPr>
           <a:xfrm>
-            <a:off x="3383280" y="1481328"/>
-            <a:ext cx="2468880" cy="457200"/>
-          </a:xfrm>
-          <a:prstGeom prst="rect">
-            <a:avLst/>
-          </a:prstGeom>
-          <a:noFill/>
-          <a:ln/>
-        </p:spPr>
-        <p:txBody>
-          <a:bodyPr wrap="square" lIns="0" tIns="0" rIns="0" bIns="0" rtlCol="0" anchor="ctr"/>
-          <a:lstStyle/>
-          <a:p>
-            <a:pPr indent="0" marL="0">
-              <a:buNone/>
-            </a:pPr>
-            <a:r>
-              <a:rPr lang="en-US" sz="3000" b="1" dirty="0">
+            <a:off x="2350008" y="1417320"/>
+            <a:ext cx="1536192" cy="365760"/>
+          </a:xfrm>
+          <a:prstGeom prst="rect">
+            <a:avLst/>
+          </a:prstGeom>
+          <a:noFill/>
+          <a:ln/>
+        </p:spPr>
+        <p:txBody>
+          <a:bodyPr wrap="square" lIns="0" tIns="0" rIns="0" bIns="0" rtlCol="0" anchor="ctr"/>
+          <a:lstStyle/>
+          <a:p>
+            <a:pPr indent="0" marL="0">
+              <a:buNone/>
+            </a:pPr>
+            <a:r>
+              <a:rPr lang="en-US" sz="2200" b="1" dirty="0">
                 <a:solidFill>
                   <a:srgbClr val="0C0C0C"/>
                 </a:solidFill>
@@ -1230,7 +1230,7 @@
               </a:rPr>
               <a:t>50+</a:t>
             </a:r>
-            <a:endParaRPr lang="en-US" sz="3000" dirty="0"/>
+            <a:endParaRPr lang="en-US" sz="2200" dirty="0"/>
           </a:p>
         </p:txBody>
       </p:sp>
@@ -1242,24 +1242,24 @@
         </p:nvSpPr>
         <p:spPr>
           <a:xfrm>
-            <a:off x="3383280" y="1911096"/>
-            <a:ext cx="2468880" cy="228600"/>
-          </a:xfrm>
-          <a:prstGeom prst="rect">
-            <a:avLst/>
-          </a:prstGeom>
-          <a:noFill/>
-          <a:ln/>
-        </p:spPr>
-        <p:txBody>
-          <a:bodyPr wrap="square" lIns="0" tIns="0" rIns="0" bIns="0" rtlCol="0" anchor="ctr"/>
-          <a:lstStyle/>
-          <a:p>
-            <a:pPr indent="0" marL="0">
-              <a:buNone/>
-            </a:pPr>
-            <a:r>
-              <a:rPr lang="en-US" sz="1050" dirty="0">
+            <a:off x="2350008" y="1764792"/>
+            <a:ext cx="1536192" cy="201168"/>
+          </a:xfrm>
+          <a:prstGeom prst="rect">
+            <a:avLst/>
+          </a:prstGeom>
+          <a:noFill/>
+          <a:ln/>
+        </p:spPr>
+        <p:txBody>
+          <a:bodyPr wrap="square" lIns="0" tIns="0" rIns="0" bIns="0" rtlCol="0" anchor="ctr"/>
+          <a:lstStyle/>
+          <a:p>
+            <a:pPr indent="0" marL="0">
+              <a:buNone/>
+            </a:pPr>
+            <a:r>
+              <a:rPr lang="en-US" sz="900" dirty="0">
                 <a:solidFill>
                   <a:srgbClr val="55565B"/>
                 </a:solidFill>
@@ -1269,7 +1269,7 @@
               </a:rPr>
               <a:t>customer portals</a:t>
             </a:r>
-            <a:endParaRPr lang="en-US" sz="1050" dirty="0"/>
+            <a:endParaRPr lang="en-US" sz="900" dirty="0"/>
           </a:p>
         </p:txBody>
       </p:sp>
@@ -1281,24 +1281,24 @@
         </p:nvSpPr>
         <p:spPr>
           <a:xfrm>
-            <a:off x="777240" y="2231136"/>
-            <a:ext cx="2468880" cy="457200"/>
-          </a:xfrm>
-          <a:prstGeom prst="rect">
-            <a:avLst/>
-          </a:prstGeom>
-          <a:noFill/>
-          <a:ln/>
-        </p:spPr>
-        <p:txBody>
-          <a:bodyPr wrap="square" lIns="0" tIns="0" rIns="0" bIns="0" rtlCol="0" anchor="ctr"/>
-          <a:lstStyle/>
-          <a:p>
-            <a:pPr indent="0" marL="0">
-              <a:buNone/>
-            </a:pPr>
-            <a:r>
-              <a:rPr lang="en-US" sz="3000" b="1" dirty="0">
+            <a:off x="722376" y="2112264"/>
+            <a:ext cx="1536192" cy="365760"/>
+          </a:xfrm>
+          <a:prstGeom prst="rect">
+            <a:avLst/>
+          </a:prstGeom>
+          <a:noFill/>
+          <a:ln/>
+        </p:spPr>
+        <p:txBody>
+          <a:bodyPr wrap="square" lIns="0" tIns="0" rIns="0" bIns="0" rtlCol="0" anchor="ctr"/>
+          <a:lstStyle/>
+          <a:p>
+            <a:pPr indent="0" marL="0">
+              <a:buNone/>
+            </a:pPr>
+            <a:r>
+              <a:rPr lang="en-US" sz="2200" b="1" dirty="0">
                 <a:solidFill>
                   <a:srgbClr val="0C0C0C"/>
                 </a:solidFill>
@@ -1308,7 +1308,7 @@
               </a:rPr>
               <a:t>40+</a:t>
             </a:r>
-            <a:endParaRPr lang="en-US" sz="3000" dirty="0"/>
+            <a:endParaRPr lang="en-US" sz="2200" dirty="0"/>
           </a:p>
         </p:txBody>
       </p:sp>
@@ -1320,24 +1320,24 @@
         </p:nvSpPr>
         <p:spPr>
           <a:xfrm>
-            <a:off x="777240" y="2660904"/>
-            <a:ext cx="2468880" cy="228600"/>
-          </a:xfrm>
-          <a:prstGeom prst="rect">
-            <a:avLst/>
-          </a:prstGeom>
-          <a:noFill/>
-          <a:ln/>
-        </p:spPr>
-        <p:txBody>
-          <a:bodyPr wrap="square" lIns="0" tIns="0" rIns="0" bIns="0" rtlCol="0" anchor="ctr"/>
-          <a:lstStyle/>
-          <a:p>
-            <a:pPr indent="0" marL="0">
-              <a:buNone/>
-            </a:pPr>
-            <a:r>
-              <a:rPr lang="en-US" sz="1050" dirty="0">
+            <a:off x="722376" y="2459736"/>
+            <a:ext cx="1536192" cy="201168"/>
+          </a:xfrm>
+          <a:prstGeom prst="rect">
+            <a:avLst/>
+          </a:prstGeom>
+          <a:noFill/>
+          <a:ln/>
+        </p:spPr>
+        <p:txBody>
+          <a:bodyPr wrap="square" lIns="0" tIns="0" rIns="0" bIns="0" rtlCol="0" anchor="ctr"/>
+          <a:lstStyle/>
+          <a:p>
+            <a:pPr indent="0" marL="0">
+              <a:buNone/>
+            </a:pPr>
+            <a:r>
+              <a:rPr lang="en-US" sz="900" dirty="0">
                 <a:solidFill>
                   <a:srgbClr val="55565B"/>
                 </a:solidFill>
@@ -1347,7 +1347,7 @@
               </a:rPr>
               <a:t>integration points</a:t>
             </a:r>
-            <a:endParaRPr lang="en-US" sz="1050" dirty="0"/>
+            <a:endParaRPr lang="en-US" sz="900" dirty="0"/>
           </a:p>
         </p:txBody>
       </p:sp>
@@ -1359,24 +1359,24 @@
         </p:nvSpPr>
         <p:spPr>
           <a:xfrm>
-            <a:off x="3383280" y="2231136"/>
-            <a:ext cx="2468880" cy="457200"/>
-          </a:xfrm>
-          <a:prstGeom prst="rect">
-            <a:avLst/>
-          </a:prstGeom>
-          <a:noFill/>
-          <a:ln/>
-        </p:spPr>
-        <p:txBody>
-          <a:bodyPr wrap="square" lIns="0" tIns="0" rIns="0" bIns="0" rtlCol="0" anchor="ctr"/>
-          <a:lstStyle/>
-          <a:p>
-            <a:pPr indent="0" marL="0">
-              <a:buNone/>
-            </a:pPr>
-            <a:r>
-              <a:rPr lang="en-US" sz="3000" b="1" dirty="0">
+            <a:off x="2350008" y="2112264"/>
+            <a:ext cx="1536192" cy="365760"/>
+          </a:xfrm>
+          <a:prstGeom prst="rect">
+            <a:avLst/>
+          </a:prstGeom>
+          <a:noFill/>
+          <a:ln/>
+        </p:spPr>
+        <p:txBody>
+          <a:bodyPr wrap="square" lIns="0" tIns="0" rIns="0" bIns="0" rtlCol="0" anchor="ctr"/>
+          <a:lstStyle/>
+          <a:p>
+            <a:pPr indent="0" marL="0">
+              <a:buNone/>
+            </a:pPr>
+            <a:r>
+              <a:rPr lang="en-US" sz="2200" b="1" dirty="0">
                 <a:solidFill>
                   <a:srgbClr val="0C0C0C"/>
                 </a:solidFill>
@@ -1386,7 +1386,7 @@
               </a:rPr>
               <a:t>~45%</a:t>
             </a:r>
-            <a:endParaRPr lang="en-US" sz="3000" dirty="0"/>
+            <a:endParaRPr lang="en-US" sz="2200" dirty="0"/>
           </a:p>
         </p:txBody>
       </p:sp>
@@ -1398,24 +1398,24 @@
         </p:nvSpPr>
         <p:spPr>
           <a:xfrm>
-            <a:off x="3383280" y="2660904"/>
-            <a:ext cx="2468880" cy="228600"/>
-          </a:xfrm>
-          <a:prstGeom prst="rect">
-            <a:avLst/>
-          </a:prstGeom>
-          <a:noFill/>
-          <a:ln/>
-        </p:spPr>
-        <p:txBody>
-          <a:bodyPr wrap="square" lIns="0" tIns="0" rIns="0" bIns="0" rtlCol="0" anchor="ctr"/>
-          <a:lstStyle/>
-          <a:p>
-            <a:pPr indent="0" marL="0">
-              <a:buNone/>
-            </a:pPr>
-            <a:r>
-              <a:rPr lang="en-US" sz="1050" dirty="0">
+            <a:off x="2350008" y="2459736"/>
+            <a:ext cx="1536192" cy="201168"/>
+          </a:xfrm>
+          <a:prstGeom prst="rect">
+            <a:avLst/>
+          </a:prstGeom>
+          <a:noFill/>
+          <a:ln/>
+        </p:spPr>
+        <p:txBody>
+          <a:bodyPr wrap="square" lIns="0" tIns="0" rIns="0" bIns="0" rtlCol="0" anchor="ctr"/>
+          <a:lstStyle/>
+          <a:p>
+            <a:pPr indent="0" marL="0">
+              <a:buNone/>
+            </a:pPr>
+            <a:r>
+              <a:rPr lang="en-US" sz="900" dirty="0">
                 <a:solidFill>
                   <a:srgbClr val="55565B"/>
                 </a:solidFill>
@@ -1425,7 +1425,7 @@
               </a:rPr>
               <a:t>of tech capex in KTLO¹</a:t>
             </a:r>
-            <a:endParaRPr lang="en-US" sz="1050" dirty="0"/>
+            <a:endParaRPr lang="en-US" sz="900" dirty="0"/>
           </a:p>
         </p:txBody>
       </p:sp>
@@ -1437,8 +1437,8 @@
         </p:nvSpPr>
         <p:spPr>
           <a:xfrm>
-            <a:off x="777240" y="2907792"/>
-            <a:ext cx="4929988" cy="0"/>
+            <a:off x="722376" y="2816352"/>
+            <a:ext cx="3155594" cy="0"/>
           </a:xfrm>
           <a:prstGeom prst="line">
             <a:avLst/>
@@ -1460,24 +1460,24 @@
         </p:nvSpPr>
         <p:spPr>
           <a:xfrm>
-            <a:off x="777240" y="2962656"/>
-            <a:ext cx="4929988" cy="237744"/>
-          </a:xfrm>
-          <a:prstGeom prst="rect">
-            <a:avLst/>
-          </a:prstGeom>
-          <a:noFill/>
-          <a:ln/>
-        </p:spPr>
-        <p:txBody>
-          <a:bodyPr wrap="square" lIns="0" tIns="0" rIns="0" bIns="0" rtlCol="0" anchor="ctr"/>
-          <a:lstStyle/>
-          <a:p>
-            <a:pPr indent="0" marL="0">
-              <a:buNone/>
-            </a:pPr>
-            <a:r>
-              <a:rPr lang="en-US" sz="1100" dirty="0">
+            <a:off x="722376" y="2880360"/>
+            <a:ext cx="3155594" cy="292608"/>
+          </a:xfrm>
+          <a:prstGeom prst="rect">
+            <a:avLst/>
+          </a:prstGeom>
+          <a:noFill/>
+          <a:ln/>
+        </p:spPr>
+        <p:txBody>
+          <a:bodyPr wrap="square" lIns="0" tIns="0" rIns="0" bIns="0" rtlCol="0" anchor="ctr"/>
+          <a:lstStyle/>
+          <a:p>
+            <a:pPr indent="0" marL="0">
+              <a:buNone/>
+            </a:pPr>
+            <a:r>
+              <a:rPr lang="en-US" sz="950" dirty="0">
                 <a:solidFill>
                   <a:srgbClr val="55565B"/>
                 </a:solidFill>
@@ -1491,7 +1491,7 @@
               <a:buNone/>
             </a:pPr>
             <a:r>
-              <a:rPr lang="en-US" sz="1100" b="1" dirty="0">
+              <a:rPr lang="en-US" sz="950" b="1" dirty="0">
                 <a:solidFill>
                   <a:srgbClr val="0C0C0C"/>
                 </a:solidFill>
@@ -1505,7 +1505,7 @@
               <a:buNone/>
             </a:pPr>
             <a:r>
-              <a:rPr lang="en-US" sz="1100" dirty="0">
+              <a:rPr lang="en-US" sz="950" dirty="0">
                 <a:solidFill>
                   <a:srgbClr val="55565B"/>
                 </a:solidFill>
@@ -1513,9 +1513,9 @@
                 <a:ea typeface="DM Sans" pitchFamily="34" charset="-122"/>
                 <a:cs typeface="DM Sans" pitchFamily="34" charset="-120"/>
               </a:rPr>
-              <a:t> — limited capacity to self-fund the shift</a:t>
-            </a:r>
-            <a:endParaRPr lang="en-US" sz="1100" dirty="0"/>
+              <a:t> — can’t self-fund the shift</a:t>
+            </a:r>
+            <a:endParaRPr lang="en-US" sz="950" dirty="0"/>
           </a:p>
         </p:txBody>
       </p:sp>
@@ -1527,8 +1527,8 @@
         </p:nvSpPr>
         <p:spPr>
           <a:xfrm>
-            <a:off x="6210148" y="914400"/>
-            <a:ext cx="5478628" cy="2331720"/>
+            <a:off x="4298594" y="914400"/>
+            <a:ext cx="3594506" cy="2331720"/>
           </a:xfrm>
           <a:prstGeom prst="roundRect">
             <a:avLst>
@@ -1549,8 +1549,8 @@
         </p:nvSpPr>
         <p:spPr>
           <a:xfrm>
-            <a:off x="6484468" y="1097280"/>
-            <a:ext cx="4929988" cy="274320"/>
+            <a:off x="4518050" y="1078992"/>
+            <a:ext cx="3155594" cy="256032"/>
           </a:xfrm>
           <a:prstGeom prst="rect">
             <a:avLst/>
@@ -1566,7 +1566,7 @@
               <a:buNone/>
             </a:pPr>
             <a:r>
-              <a:rPr lang="en-US" sz="1100" b="1" spc="200" kern="0" dirty="0">
+              <a:rPr lang="en-US" sz="1050" b="1" spc="200" kern="0" dirty="0">
                 <a:solidFill>
                   <a:srgbClr val="262AFF"/>
                 </a:solidFill>
@@ -1574,9 +1574,9 @@
                 <a:ea typeface="DM Sans" pitchFamily="34" charset="-122"/>
                 <a:cs typeface="DM Sans" pitchFamily="34" charset="-120"/>
               </a:rPr>
-              <a:t>WAITING GETS MORE EXPENSIVE EVERY QUARTER</a:t>
-            </a:r>
-            <a:endParaRPr lang="en-US" sz="1100" dirty="0"/>
+              <a:t>WAITING GETS MORE EXPENSIVE</a:t>
+            </a:r>
+            <a:endParaRPr lang="en-US" sz="1050" dirty="0"/>
           </a:p>
         </p:txBody>
       </p:sp>
@@ -1588,8 +1588,8 @@
         </p:nvSpPr>
         <p:spPr>
           <a:xfrm>
-            <a:off x="6484468" y="1481328"/>
-            <a:ext cx="420624" cy="420624"/>
+            <a:off x="4518050" y="1426464"/>
+            <a:ext cx="365760" cy="365760"/>
           </a:xfrm>
           <a:prstGeom prst="ellipse">
             <a:avLst/>
@@ -1616,8 +1616,8 @@
         </p:blipFill>
         <p:spPr>
           <a:xfrm>
-            <a:off x="6577005" y="1573865"/>
-            <a:ext cx="235549" cy="235549"/>
+            <a:off x="4598518" y="1506931"/>
+            <a:ext cx="204826" cy="204826"/>
           </a:xfrm>
           <a:prstGeom prst="rect">
             <a:avLst/>
@@ -1632,24 +1632,24 @@
         </p:nvSpPr>
         <p:spPr>
           <a:xfrm>
-            <a:off x="7051396" y="1435608"/>
-            <a:ext cx="4335628" cy="530352"/>
-          </a:xfrm>
-          <a:prstGeom prst="rect">
-            <a:avLst/>
-          </a:prstGeom>
-          <a:noFill/>
-          <a:ln/>
-        </p:spPr>
-        <p:txBody>
-          <a:bodyPr wrap="square" lIns="0" tIns="0" rIns="0" bIns="0" rtlCol="0" anchor="ctr"/>
-          <a:lstStyle/>
-          <a:p>
-            <a:pPr indent="0" marL="0">
-              <a:buNone/>
-            </a:pPr>
-            <a:r>
-              <a:rPr lang="en-US" sz="1250" b="1" dirty="0">
+            <a:off x="4993538" y="1353312"/>
+            <a:ext cx="2680106" cy="548640"/>
+          </a:xfrm>
+          <a:prstGeom prst="rect">
+            <a:avLst/>
+          </a:prstGeom>
+          <a:noFill/>
+          <a:ln/>
+        </p:spPr>
+        <p:txBody>
+          <a:bodyPr wrap="square" lIns="0" tIns="0" rIns="0" bIns="0" rtlCol="0" anchor="ctr"/>
+          <a:lstStyle/>
+          <a:p>
+            <a:pPr indent="0" marL="0">
+              <a:buNone/>
+            </a:pPr>
+            <a:r>
+              <a:rPr lang="en-US" sz="1100" b="1" dirty="0">
                 <a:solidFill>
                   <a:srgbClr val="0C0C0C"/>
                 </a:solidFill>
@@ -1657,13 +1657,13 @@
                 <a:ea typeface="DM Sans" pitchFamily="34" charset="-122"/>
                 <a:cs typeface="DM Sans" pitchFamily="34" charset="-120"/>
               </a:rPr>
-              <a:t>Customers expect one experience</a:t>
-            </a:r>
-            <a:pPr indent="0" marL="0">
-              <a:buNone/>
-            </a:pPr>
-            <a:r>
-              <a:rPr lang="en-US" sz="1250" dirty="0">
+              <a:t>One experience expected</a:t>
+            </a:r>
+            <a:pPr indent="0" marL="0">
+              <a:buNone/>
+            </a:pPr>
+            <a:r>
+              <a:rPr lang="en-US" sz="1100" dirty="0">
                 <a:solidFill>
                   <a:srgbClr val="55565B"/>
                 </a:solidFill>
@@ -1671,9 +1671,9 @@
                 <a:ea typeface="DM Sans" pitchFamily="34" charset="-122"/>
                 <a:cs typeface="DM Sans" pitchFamily="34" charset="-120"/>
               </a:rPr>
-              <a:t> — digital-first rivals activate merchants in hours, not weeks</a:t>
-            </a:r>
-            <a:endParaRPr lang="en-US" sz="1250" dirty="0"/>
+              <a:t> — rivals activate in hours, not weeks</a:t>
+            </a:r>
+            <a:endParaRPr lang="en-US" sz="1100" dirty="0"/>
           </a:p>
         </p:txBody>
       </p:sp>
@@ -1685,8 +1685,8 @@
         </p:nvSpPr>
         <p:spPr>
           <a:xfrm>
-            <a:off x="6484468" y="2066544"/>
-            <a:ext cx="420624" cy="420624"/>
+            <a:off x="4518050" y="2029968"/>
+            <a:ext cx="365760" cy="365760"/>
           </a:xfrm>
           <a:prstGeom prst="ellipse">
             <a:avLst/>
@@ -1713,8 +1713,8 @@
         </p:blipFill>
         <p:spPr>
           <a:xfrm>
-            <a:off x="6577005" y="2159081"/>
-            <a:ext cx="235549" cy="235549"/>
+            <a:off x="4598518" y="2110435"/>
+            <a:ext cx="204826" cy="204826"/>
           </a:xfrm>
           <a:prstGeom prst="rect">
             <a:avLst/>
@@ -1729,24 +1729,24 @@
         </p:nvSpPr>
         <p:spPr>
           <a:xfrm>
-            <a:off x="7051396" y="2020824"/>
-            <a:ext cx="4335628" cy="530352"/>
-          </a:xfrm>
-          <a:prstGeom prst="rect">
-            <a:avLst/>
-          </a:prstGeom>
-          <a:noFill/>
-          <a:ln/>
-        </p:spPr>
-        <p:txBody>
-          <a:bodyPr wrap="square" lIns="0" tIns="0" rIns="0" bIns="0" rtlCol="0" anchor="ctr"/>
-          <a:lstStyle/>
-          <a:p>
-            <a:pPr indent="0" marL="0">
-              <a:buNone/>
-            </a:pPr>
-            <a:r>
-              <a:rPr lang="en-US" sz="1250" b="1" dirty="0">
+            <a:off x="4993538" y="1956816"/>
+            <a:ext cx="2680106" cy="548640"/>
+          </a:xfrm>
+          <a:prstGeom prst="rect">
+            <a:avLst/>
+          </a:prstGeom>
+          <a:noFill/>
+          <a:ln/>
+        </p:spPr>
+        <p:txBody>
+          <a:bodyPr wrap="square" lIns="0" tIns="0" rIns="0" bIns="0" rtlCol="0" anchor="ctr"/>
+          <a:lstStyle/>
+          <a:p>
+            <a:pPr indent="0" marL="0">
+              <a:buNone/>
+            </a:pPr>
+            <a:r>
+              <a:rPr lang="en-US" sz="1100" b="1" dirty="0">
                 <a:solidFill>
                   <a:srgbClr val="0C0C0C"/>
                 </a:solidFill>
@@ -1754,13 +1754,13 @@
                 <a:ea typeface="DM Sans" pitchFamily="34" charset="-122"/>
                 <a:cs typeface="DM Sans" pitchFamily="34" charset="-120"/>
               </a:rPr>
-              <a:t>Innovation perception gap</a:t>
-            </a:r>
-            <a:pPr indent="0" marL="0">
-              <a:buNone/>
-            </a:pPr>
-            <a:r>
-              <a:rPr lang="en-US" sz="1250" dirty="0">
+              <a:t>Perception gap</a:t>
+            </a:r>
+            <a:pPr indent="0" marL="0">
+              <a:buNone/>
+            </a:pPr>
+            <a:r>
+              <a:rPr lang="en-US" sz="1100" dirty="0">
                 <a:solidFill>
                   <a:srgbClr val="55565B"/>
                 </a:solidFill>
@@ -1768,9 +1768,9 @@
                 <a:ea typeface="DM Sans" pitchFamily="34" charset="-122"/>
                 <a:cs typeface="DM Sans" pitchFamily="34" charset="-120"/>
               </a:rPr>
-              <a:t> limits GP’s inclusion in RFPs today</a:t>
-            </a:r>
-            <a:endParaRPr lang="en-US" sz="1250" dirty="0"/>
+              <a:t> limits GP’s inclusion in RFPs</a:t>
+            </a:r>
+            <a:endParaRPr lang="en-US" sz="1100" dirty="0"/>
           </a:p>
         </p:txBody>
       </p:sp>
@@ -1782,8 +1782,8 @@
         </p:nvSpPr>
         <p:spPr>
           <a:xfrm>
-            <a:off x="6484468" y="2651760"/>
-            <a:ext cx="420624" cy="420624"/>
+            <a:off x="4518050" y="2633472"/>
+            <a:ext cx="365760" cy="365760"/>
           </a:xfrm>
           <a:prstGeom prst="ellipse">
             <a:avLst/>
@@ -1810,8 +1810,8 @@
         </p:blipFill>
         <p:spPr>
           <a:xfrm>
-            <a:off x="6577005" y="2744297"/>
-            <a:ext cx="235549" cy="235549"/>
+            <a:off x="4598518" y="2713939"/>
+            <a:ext cx="204826" cy="204826"/>
           </a:xfrm>
           <a:prstGeom prst="rect">
             <a:avLst/>
@@ -1826,24 +1826,24 @@
         </p:nvSpPr>
         <p:spPr>
           <a:xfrm>
-            <a:off x="7051396" y="2606040"/>
-            <a:ext cx="4335628" cy="530352"/>
-          </a:xfrm>
-          <a:prstGeom prst="rect">
-            <a:avLst/>
-          </a:prstGeom>
-          <a:noFill/>
-          <a:ln/>
-        </p:spPr>
-        <p:txBody>
-          <a:bodyPr wrap="square" lIns="0" tIns="0" rIns="0" bIns="0" rtlCol="0" anchor="ctr"/>
-          <a:lstStyle/>
-          <a:p>
-            <a:pPr indent="0" marL="0">
-              <a:buNone/>
-            </a:pPr>
-            <a:r>
-              <a:rPr lang="en-US" sz="1250" b="1" dirty="0">
+            <a:off x="4993538" y="2560320"/>
+            <a:ext cx="2680106" cy="548640"/>
+          </a:xfrm>
+          <a:prstGeom prst="rect">
+            <a:avLst/>
+          </a:prstGeom>
+          <a:noFill/>
+          <a:ln/>
+        </p:spPr>
+        <p:txBody>
+          <a:bodyPr wrap="square" lIns="0" tIns="0" rIns="0" bIns="0" rtlCol="0" anchor="ctr"/>
+          <a:lstStyle/>
+          <a:p>
+            <a:pPr indent="0" marL="0">
+              <a:buNone/>
+            </a:pPr>
+            <a:r>
+              <a:rPr lang="en-US" sz="1100" b="1" dirty="0">
                 <a:solidFill>
                   <a:srgbClr val="0C0C0C"/>
                 </a:solidFill>
@@ -1851,13 +1851,13 @@
                 <a:ea typeface="DM Sans" pitchFamily="34" charset="-122"/>
                 <a:cs typeface="DM Sans" pitchFamily="34" charset="-120"/>
               </a:rPr>
-              <a:t>Post-merger synergy targets</a:t>
-            </a:r>
-            <a:pPr indent="0" marL="0">
-              <a:buNone/>
-            </a:pPr>
-            <a:r>
-              <a:rPr lang="en-US" sz="1250" dirty="0">
+              <a:t>Synergy targets</a:t>
+            </a:r>
+            <a:pPr indent="0" marL="0">
+              <a:buNone/>
+            </a:pPr>
+            <a:r>
+              <a:rPr lang="en-US" sz="1100" dirty="0">
                 <a:solidFill>
                   <a:srgbClr val="55565B"/>
                 </a:solidFill>
@@ -1865,9 +1865,9 @@
                 <a:ea typeface="DM Sans" pitchFamily="34" charset="-122"/>
                 <a:cs typeface="DM Sans" pitchFamily="34" charset="-120"/>
               </a:rPr>
-              <a:t> are predicated on a simplified estate</a:t>
-            </a:r>
-            <a:endParaRPr lang="en-US" sz="1250" dirty="0"/>
+              <a:t> assume a simplified estate</a:t>
+            </a:r>
+            <a:endParaRPr lang="en-US" sz="1100" dirty="0"/>
           </a:p>
         </p:txBody>
       </p:sp>
@@ -1879,8 +1879,8 @@
         </p:nvSpPr>
         <p:spPr>
           <a:xfrm>
-            <a:off x="502920" y="3456432"/>
-            <a:ext cx="5478628" cy="2331720"/>
+            <a:off x="8094269" y="914400"/>
+            <a:ext cx="3594506" cy="2331720"/>
           </a:xfrm>
           <a:prstGeom prst="roundRect">
             <a:avLst>
@@ -1888,7 +1888,7 @@
             </a:avLst>
           </a:prstGeom>
           <a:solidFill>
-            <a:srgbClr val="E9E9FC"/>
+            <a:srgbClr val="F4F4F6"/>
           </a:solidFill>
           <a:ln/>
         </p:spPr>
@@ -1901,8 +1901,8 @@
         </p:nvSpPr>
         <p:spPr>
           <a:xfrm>
-            <a:off x="777240" y="3639312"/>
-            <a:ext cx="4929988" cy="274320"/>
+            <a:off x="8313725" y="1078992"/>
+            <a:ext cx="3155594" cy="256032"/>
           </a:xfrm>
           <a:prstGeom prst="rect">
             <a:avLst/>
@@ -1918,7 +1918,7 @@
               <a:buNone/>
             </a:pPr>
             <a:r>
-              <a:rPr lang="en-US" sz="1100" b="1" spc="200" kern="0" dirty="0">
+              <a:rPr lang="en-US" sz="1050" b="1" spc="200" kern="0" dirty="0">
                 <a:solidFill>
                   <a:srgbClr val="262AFF"/>
                 </a:solidFill>
@@ -1926,9 +1926,9 @@
                 <a:ea typeface="DM Sans" pitchFamily="34" charset="-122"/>
                 <a:cs typeface="DM Sans" pitchFamily="34" charset="-120"/>
               </a:rPr>
-              <a:t>ONE PLAN: EXPERIENCE FIRST, THEN BACK-ENDS</a:t>
-            </a:r>
-            <a:endParaRPr lang="en-US" sz="1100" dirty="0"/>
+              <a:t>THE MODEL IS ALREADY PROVEN</a:t>
+            </a:r>
+            <a:endParaRPr lang="en-US" sz="1050" dirty="0"/>
           </a:p>
         </p:txBody>
       </p:sp>
@@ -1940,34 +1940,34 @@
         </p:nvSpPr>
         <p:spPr>
           <a:xfrm>
-            <a:off x="777240" y="4005072"/>
-            <a:ext cx="2103120" cy="685800"/>
-          </a:xfrm>
-          <a:prstGeom prst="rect">
-            <a:avLst/>
-          </a:prstGeom>
-          <a:noFill/>
-          <a:ln/>
-        </p:spPr>
-        <p:txBody>
-          <a:bodyPr wrap="square" lIns="0" tIns="0" rIns="0" bIns="0" rtlCol="0" anchor="ctr"/>
-          <a:lstStyle/>
-          <a:p>
-            <a:pPr indent="0" marL="0">
-              <a:buNone/>
-            </a:pPr>
-            <a:r>
-              <a:rPr lang="en-US" sz="4400" b="1" dirty="0">
-                <a:solidFill>
-                  <a:srgbClr val="262AFF"/>
-                </a:solidFill>
-                <a:latin typeface="DM Sans" pitchFamily="34" charset="0"/>
-                <a:ea typeface="DM Sans" pitchFamily="34" charset="-122"/>
-                <a:cs typeface="DM Sans" pitchFamily="34" charset="-120"/>
-              </a:rPr>
-              <a:t>&gt;80%</a:t>
-            </a:r>
-            <a:endParaRPr lang="en-US" sz="4400" dirty="0"/>
+            <a:off x="8313725" y="1417320"/>
+            <a:ext cx="1536192" cy="365760"/>
+          </a:xfrm>
+          <a:prstGeom prst="rect">
+            <a:avLst/>
+          </a:prstGeom>
+          <a:noFill/>
+          <a:ln/>
+        </p:spPr>
+        <p:txBody>
+          <a:bodyPr wrap="square" lIns="0" tIns="0" rIns="0" bIns="0" rtlCol="0" anchor="ctr"/>
+          <a:lstStyle/>
+          <a:p>
+            <a:pPr indent="0" marL="0">
+              <a:buNone/>
+            </a:pPr>
+            <a:r>
+              <a:rPr lang="en-US" sz="2200" b="1" dirty="0">
+                <a:solidFill>
+                  <a:srgbClr val="0C0C0C"/>
+                </a:solidFill>
+                <a:latin typeface="DM Sans" pitchFamily="34" charset="0"/>
+                <a:ea typeface="DM Sans" pitchFamily="34" charset="-122"/>
+                <a:cs typeface="DM Sans" pitchFamily="34" charset="-120"/>
+              </a:rPr>
+              <a:t>60+</a:t>
+            </a:r>
+            <a:endParaRPr lang="en-US" sz="2200" dirty="0"/>
           </a:p>
         </p:txBody>
       </p:sp>
@@ -1979,24 +1979,24 @@
         </p:nvSpPr>
         <p:spPr>
           <a:xfrm>
-            <a:off x="777240" y="4690872"/>
-            <a:ext cx="1965960" cy="548640"/>
-          </a:xfrm>
-          <a:prstGeom prst="rect">
-            <a:avLst/>
-          </a:prstGeom>
-          <a:noFill/>
-          <a:ln/>
-        </p:spPr>
-        <p:txBody>
-          <a:bodyPr wrap="square" lIns="0" tIns="0" rIns="0" bIns="0" rtlCol="0" anchor="ctr"/>
-          <a:lstStyle/>
-          <a:p>
-            <a:pPr indent="0" marL="0">
-              <a:buNone/>
-            </a:pPr>
-            <a:r>
-              <a:rPr lang="en-US" sz="1100" dirty="0">
+            <a:off x="8313725" y="1764792"/>
+            <a:ext cx="1536192" cy="201168"/>
+          </a:xfrm>
+          <a:prstGeom prst="rect">
+            <a:avLst/>
+          </a:prstGeom>
+          <a:noFill/>
+          <a:ln/>
+        </p:spPr>
+        <p:txBody>
+          <a:bodyPr wrap="square" lIns="0" tIns="0" rIns="0" bIns="0" rtlCol="0" anchor="ctr"/>
+          <a:lstStyle/>
+          <a:p>
+            <a:pPr indent="0" marL="0">
+              <a:buNone/>
+            </a:pPr>
+            <a:r>
+              <a:rPr lang="en-US" sz="900" dirty="0">
                 <a:solidFill>
                   <a:srgbClr val="55565B"/>
                 </a:solidFill>
@@ -2004,16 +2004,77 @@
                 <a:ea typeface="DM Sans" pitchFamily="34" charset="-122"/>
                 <a:cs typeface="DM Sans" pitchFamily="34" charset="-120"/>
               </a:rPr>
-              <a:t>smaller platform estate,</a:t>
-            </a:r>
-            <a:endParaRPr lang="en-US" sz="1100" dirty="0"/>
-          </a:p>
-          <a:p>
-            <a:pPr indent="0" marL="0">
-              <a:buNone/>
-            </a:pPr>
-            <a:r>
-              <a:rPr lang="en-US" sz="1100" dirty="0">
+              <a:t>platforms retired²</a:t>
+            </a:r>
+            <a:endParaRPr lang="en-US" sz="900" dirty="0"/>
+          </a:p>
+        </p:txBody>
+      </p:sp>
+      <p:sp>
+        <p:nvSpPr>
+          <p:cNvPr id="31" name="Text 26"/>
+          <p:cNvSpPr/>
+          <p:nvPr/>
+        </p:nvSpPr>
+        <p:spPr>
+          <a:xfrm>
+            <a:off x="9941357" y="1417320"/>
+            <a:ext cx="1536192" cy="365760"/>
+          </a:xfrm>
+          <a:prstGeom prst="rect">
+            <a:avLst/>
+          </a:prstGeom>
+          <a:noFill/>
+          <a:ln/>
+        </p:spPr>
+        <p:txBody>
+          <a:bodyPr wrap="square" lIns="0" tIns="0" rIns="0" bIns="0" rtlCol="0" anchor="ctr"/>
+          <a:lstStyle/>
+          <a:p>
+            <a:pPr indent="0" marL="0">
+              <a:buNone/>
+            </a:pPr>
+            <a:r>
+              <a:rPr lang="en-US" sz="2200" b="1" dirty="0">
+                <a:solidFill>
+                  <a:srgbClr val="0C0C0C"/>
+                </a:solidFill>
+                <a:latin typeface="DM Sans" pitchFamily="34" charset="0"/>
+                <a:ea typeface="DM Sans" pitchFamily="34" charset="-122"/>
+                <a:cs typeface="DM Sans" pitchFamily="34" charset="-120"/>
+              </a:rPr>
+              <a:t>180K+</a:t>
+            </a:r>
+            <a:endParaRPr lang="en-US" sz="2200" dirty="0"/>
+          </a:p>
+        </p:txBody>
+      </p:sp>
+      <p:sp>
+        <p:nvSpPr>
+          <p:cNvPr id="32" name="Text 27"/>
+          <p:cNvSpPr/>
+          <p:nvPr/>
+        </p:nvSpPr>
+        <p:spPr>
+          <a:xfrm>
+            <a:off x="9941357" y="1764792"/>
+            <a:ext cx="1536192" cy="201168"/>
+          </a:xfrm>
+          <a:prstGeom prst="rect">
+            <a:avLst/>
+          </a:prstGeom>
+          <a:noFill/>
+          <a:ln/>
+        </p:spPr>
+        <p:txBody>
+          <a:bodyPr wrap="square" lIns="0" tIns="0" rIns="0" bIns="0" rtlCol="0" anchor="ctr"/>
+          <a:lstStyle/>
+          <a:p>
+            <a:pPr indent="0" marL="0">
+              <a:buNone/>
+            </a:pPr>
+            <a:r>
+              <a:rPr lang="en-US" sz="900" dirty="0">
                 <a:solidFill>
                   <a:srgbClr val="55565B"/>
                 </a:solidFill>
@@ -2021,77 +2082,38 @@
                 <a:ea typeface="DM Sans" pitchFamily="34" charset="-122"/>
                 <a:cs typeface="DM Sans" pitchFamily="34" charset="-120"/>
               </a:rPr>
-              <a:t>one target state</a:t>
-            </a:r>
-            <a:endParaRPr lang="en-US" sz="1100" dirty="0"/>
-          </a:p>
-        </p:txBody>
-      </p:sp>
-      <p:sp>
-        <p:nvSpPr>
-          <p:cNvPr id="31" name="Shape 26"/>
-          <p:cNvSpPr/>
-          <p:nvPr/>
-        </p:nvSpPr>
-        <p:spPr>
-          <a:xfrm>
-            <a:off x="3017520" y="3931920"/>
-            <a:ext cx="2689708" cy="621792"/>
-          </a:xfrm>
-          <a:prstGeom prst="roundRect">
-            <a:avLst>
-              <a:gd name="adj" fmla="val 8824"/>
-            </a:avLst>
-          </a:prstGeom>
-          <a:solidFill>
-            <a:srgbClr val="FFFFFF"/>
-          </a:solidFill>
-          <a:ln/>
-        </p:spPr>
-      </p:sp>
-      <p:sp>
-        <p:nvSpPr>
-          <p:cNvPr id="32" name="Text 27"/>
-          <p:cNvSpPr/>
-          <p:nvPr/>
-        </p:nvSpPr>
-        <p:spPr>
-          <a:xfrm>
-            <a:off x="3182112" y="3931920"/>
-            <a:ext cx="2415388" cy="621792"/>
-          </a:xfrm>
-          <a:prstGeom prst="rect">
-            <a:avLst/>
-          </a:prstGeom>
-          <a:noFill/>
-          <a:ln/>
-        </p:spPr>
-        <p:txBody>
-          <a:bodyPr wrap="square" lIns="0" tIns="0" rIns="0" bIns="0" rtlCol="0" anchor="ctr"/>
-          <a:lstStyle/>
-          <a:p>
-            <a:pPr indent="0" marL="0">
-              <a:buNone/>
-            </a:pPr>
-            <a:r>
-              <a:rPr lang="en-US" sz="1000" b="1" spc="100" kern="0" dirty="0">
-                <a:solidFill>
-                  <a:srgbClr val="262AFF"/>
-                </a:solidFill>
-                <a:latin typeface="DM Sans" pitchFamily="34" charset="0"/>
-                <a:ea typeface="DM Sans" pitchFamily="34" charset="-122"/>
-                <a:cs typeface="DM Sans" pitchFamily="34" charset="-120"/>
-              </a:rPr>
-              <a:t>Y1–2  ·  ~$250M</a:t>
-            </a:r>
-            <a:endParaRPr lang="en-US" sz="1000" dirty="0"/>
-          </a:p>
-          <a:p>
-            <a:pPr indent="0" marL="0">
-              <a:buNone/>
-            </a:pPr>
-            <a:r>
-              <a:rPr lang="en-US" sz="1250" b="1" dirty="0">
+              <a:t>merchants on one portal</a:t>
+            </a:r>
+            <a:endParaRPr lang="en-US" sz="900" dirty="0"/>
+          </a:p>
+        </p:txBody>
+      </p:sp>
+      <p:sp>
+        <p:nvSpPr>
+          <p:cNvPr id="33" name="Text 28"/>
+          <p:cNvSpPr/>
+          <p:nvPr/>
+        </p:nvSpPr>
+        <p:spPr>
+          <a:xfrm>
+            <a:off x="8313725" y="2112264"/>
+            <a:ext cx="1536192" cy="365760"/>
+          </a:xfrm>
+          <a:prstGeom prst="rect">
+            <a:avLst/>
+          </a:prstGeom>
+          <a:noFill/>
+          <a:ln/>
+        </p:spPr>
+        <p:txBody>
+          <a:bodyPr wrap="square" lIns="0" tIns="0" rIns="0" bIns="0" rtlCol="0" anchor="ctr"/>
+          <a:lstStyle/>
+          <a:p>
+            <a:pPr indent="0" marL="0">
+              <a:buNone/>
+            </a:pPr>
+            <a:r>
+              <a:rPr lang="en-US" sz="2200" b="1" dirty="0">
                 <a:solidFill>
                   <a:srgbClr val="0C0C0C"/>
                 </a:solidFill>
@@ -2099,72 +2121,50 @@
                 <a:ea typeface="DM Sans" pitchFamily="34" charset="-122"/>
                 <a:cs typeface="DM Sans" pitchFamily="34" charset="-120"/>
               </a:rPr>
-              <a:t>Simplify the customer experience</a:t>
-            </a:r>
-            <a:endParaRPr lang="en-US" sz="1000" dirty="0"/>
-          </a:p>
-        </p:txBody>
-      </p:sp>
-      <p:sp>
-        <p:nvSpPr>
-          <p:cNvPr id="33" name="Text 28"/>
-          <p:cNvSpPr/>
-          <p:nvPr/>
-        </p:nvSpPr>
-        <p:spPr>
-          <a:xfrm rot="5400000">
-            <a:off x="4270934" y="4562856"/>
-            <a:ext cx="274320" cy="219456"/>
-          </a:xfrm>
-          <a:prstGeom prst="rect">
-            <a:avLst/>
-          </a:prstGeom>
-          <a:noFill/>
-          <a:ln/>
-        </p:spPr>
-        <p:txBody>
-          <a:bodyPr wrap="square" lIns="0" tIns="0" rIns="0" bIns="0" rtlCol="0" anchor="ctr"/>
-          <a:lstStyle/>
-          <a:p>
-            <a:pPr algn="ctr" indent="0" marL="0">
-              <a:buNone/>
-            </a:pPr>
-            <a:r>
-              <a:rPr lang="en-US" sz="1300" b="1" dirty="0">
-                <a:solidFill>
-                  <a:srgbClr val="1CABFF"/>
-                </a:solidFill>
-                <a:latin typeface="DM Sans" pitchFamily="34" charset="0"/>
-                <a:ea typeface="DM Sans" pitchFamily="34" charset="-122"/>
-                <a:cs typeface="DM Sans" pitchFamily="34" charset="-120"/>
-              </a:rPr>
-              <a:t>❯</a:t>
-            </a:r>
-            <a:endParaRPr lang="en-US" sz="1300" dirty="0"/>
-          </a:p>
-        </p:txBody>
-      </p:sp>
-      <p:sp>
-        <p:nvSpPr>
-          <p:cNvPr id="34" name="Shape 29"/>
-          <p:cNvSpPr/>
-          <p:nvPr/>
-        </p:nvSpPr>
-        <p:spPr>
-          <a:xfrm>
-            <a:off x="3017520" y="4791456"/>
-            <a:ext cx="2689708" cy="621792"/>
-          </a:xfrm>
-          <a:prstGeom prst="roundRect">
-            <a:avLst>
-              <a:gd name="adj" fmla="val 8824"/>
-            </a:avLst>
-          </a:prstGeom>
-          <a:solidFill>
-            <a:srgbClr val="FFFFFF"/>
-          </a:solidFill>
-          <a:ln/>
-        </p:spPr>
+              <a:t>–60%</a:t>
+            </a:r>
+            <a:endParaRPr lang="en-US" sz="2200" dirty="0"/>
+          </a:p>
+        </p:txBody>
+      </p:sp>
+      <p:sp>
+        <p:nvSpPr>
+          <p:cNvPr id="34" name="Text 29"/>
+          <p:cNvSpPr/>
+          <p:nvPr/>
+        </p:nvSpPr>
+        <p:spPr>
+          <a:xfrm>
+            <a:off x="8313725" y="2459736"/>
+            <a:ext cx="1536192" cy="201168"/>
+          </a:xfrm>
+          <a:prstGeom prst="rect">
+            <a:avLst/>
+          </a:prstGeom>
+          <a:noFill/>
+          <a:ln/>
+        </p:spPr>
+        <p:txBody>
+          <a:bodyPr wrap="square" lIns="0" tIns="0" rIns="0" bIns="0" rtlCol="0" anchor="ctr"/>
+          <a:lstStyle/>
+          <a:p>
+            <a:pPr indent="0" marL="0">
+              <a:buNone/>
+            </a:pPr>
+            <a:r>
+              <a:rPr lang="en-US" sz="900" dirty="0">
+                <a:solidFill>
+                  <a:srgbClr val="55565B"/>
+                </a:solidFill>
+                <a:latin typeface="DM Sans" pitchFamily="34" charset="0"/>
+                <a:ea typeface="DM Sans" pitchFamily="34" charset="-122"/>
+                <a:cs typeface="DM Sans" pitchFamily="34" charset="-120"/>
+              </a:rPr>
+              <a:t>service calls, NPS +5</a:t>
+            </a:r>
+            <a:endParaRPr lang="en-US" sz="900" dirty="0"/>
+          </a:p>
+        </p:txBody>
       </p:sp>
       <p:sp>
         <p:nvSpPr>
@@ -2174,41 +2174,24 @@
         </p:nvSpPr>
         <p:spPr>
           <a:xfrm>
-            <a:off x="3182112" y="4791456"/>
-            <a:ext cx="2415388" cy="621792"/>
-          </a:xfrm>
-          <a:prstGeom prst="rect">
-            <a:avLst/>
-          </a:prstGeom>
-          <a:noFill/>
-          <a:ln/>
-        </p:spPr>
-        <p:txBody>
-          <a:bodyPr wrap="square" lIns="0" tIns="0" rIns="0" bIns="0" rtlCol="0" anchor="ctr"/>
-          <a:lstStyle/>
-          <a:p>
-            <a:pPr indent="0" marL="0">
-              <a:buNone/>
-            </a:pPr>
-            <a:r>
-              <a:rPr lang="en-US" sz="1000" b="1" spc="100" kern="0" dirty="0">
-                <a:solidFill>
-                  <a:srgbClr val="262AFF"/>
-                </a:solidFill>
-                <a:latin typeface="DM Sans" pitchFamily="34" charset="0"/>
-                <a:ea typeface="DM Sans" pitchFamily="34" charset="-122"/>
-                <a:cs typeface="DM Sans" pitchFamily="34" charset="-120"/>
-              </a:rPr>
-              <a:t>Y3–5  ·  ~$250M</a:t>
-            </a:r>
-            <a:endParaRPr lang="en-US" sz="1000" dirty="0"/>
-          </a:p>
-          <a:p>
-            <a:pPr indent="0" marL="0">
-              <a:buNone/>
-            </a:pPr>
-            <a:r>
-              <a:rPr lang="en-US" sz="1250" b="1" dirty="0">
+            <a:off x="9941357" y="2112264"/>
+            <a:ext cx="1536192" cy="365760"/>
+          </a:xfrm>
+          <a:prstGeom prst="rect">
+            <a:avLst/>
+          </a:prstGeom>
+          <a:noFill/>
+          <a:ln/>
+        </p:spPr>
+        <p:txBody>
+          <a:bodyPr wrap="square" lIns="0" tIns="0" rIns="0" bIns="0" rtlCol="0" anchor="ctr"/>
+          <a:lstStyle/>
+          <a:p>
+            <a:pPr indent="0" marL="0">
+              <a:buNone/>
+            </a:pPr>
+            <a:r>
+              <a:rPr lang="en-US" sz="2200" b="1" dirty="0">
                 <a:solidFill>
                   <a:srgbClr val="0C0C0C"/>
                 </a:solidFill>
@@ -2216,22 +2199,61 @@
                 <a:ea typeface="DM Sans" pitchFamily="34" charset="-122"/>
                 <a:cs typeface="DM Sans" pitchFamily="34" charset="-120"/>
               </a:rPr>
-              <a:t>Consolidate the back-ends</a:t>
-            </a:r>
-            <a:endParaRPr lang="en-US" sz="1000" dirty="0"/>
-          </a:p>
-        </p:txBody>
-      </p:sp>
-      <p:sp>
-        <p:nvSpPr>
-          <p:cNvPr id="36" name="Shape 31"/>
-          <p:cNvSpPr/>
-          <p:nvPr/>
-        </p:nvSpPr>
-        <p:spPr>
-          <a:xfrm>
-            <a:off x="777240" y="5486400"/>
-            <a:ext cx="4929988" cy="0"/>
+              <a:t>13</a:t>
+            </a:r>
+            <a:endParaRPr lang="en-US" sz="2200" dirty="0"/>
+          </a:p>
+        </p:txBody>
+      </p:sp>
+      <p:sp>
+        <p:nvSpPr>
+          <p:cNvPr id="36" name="Text 31"/>
+          <p:cNvSpPr/>
+          <p:nvPr/>
+        </p:nvSpPr>
+        <p:spPr>
+          <a:xfrm>
+            <a:off x="9941357" y="2459736"/>
+            <a:ext cx="1536192" cy="201168"/>
+          </a:xfrm>
+          <a:prstGeom prst="rect">
+            <a:avLst/>
+          </a:prstGeom>
+          <a:noFill/>
+          <a:ln/>
+        </p:spPr>
+        <p:txBody>
+          <a:bodyPr wrap="square" lIns="0" tIns="0" rIns="0" bIns="0" rtlCol="0" anchor="ctr"/>
+          <a:lstStyle/>
+          <a:p>
+            <a:pPr indent="0" marL="0">
+              <a:buNone/>
+            </a:pPr>
+            <a:r>
+              <a:rPr lang="en-US" sz="900" dirty="0">
+                <a:solidFill>
+                  <a:srgbClr val="55565B"/>
+                </a:solidFill>
+                <a:latin typeface="DM Sans" pitchFamily="34" charset="0"/>
+                <a:ea typeface="DM Sans" pitchFamily="34" charset="-122"/>
+                <a:cs typeface="DM Sans" pitchFamily="34" charset="-120"/>
+              </a:rPr>
+              <a:t>days to first payment, UK</a:t>
+            </a:r>
+            <a:endParaRPr lang="en-US" sz="900" dirty="0"/>
+          </a:p>
+        </p:txBody>
+      </p:sp>
+      <p:sp>
+        <p:nvSpPr>
+          <p:cNvPr id="37" name="Shape 32"/>
+          <p:cNvSpPr/>
+          <p:nvPr/>
+        </p:nvSpPr>
+        <p:spPr>
+          <a:xfrm>
+            <a:off x="8313725" y="2816352"/>
+            <a:ext cx="3155594" cy="0"/>
           </a:xfrm>
           <a:prstGeom prst="line">
             <a:avLst/>
@@ -2239,7 +2261,7 @@
           <a:noFill/>
           <a:ln w="9525">
             <a:solidFill>
-              <a:srgbClr val="CFCFF5"/>
+              <a:srgbClr val="E2E2E6"/>
             </a:solidFill>
             <a:prstDash val="solid"/>
           </a:ln>
@@ -2247,25 +2269,39 @@
       </p:sp>
       <p:sp>
         <p:nvSpPr>
-          <p:cNvPr id="37" name="Text 32"/>
-          <p:cNvSpPr/>
-          <p:nvPr/>
-        </p:nvSpPr>
-        <p:spPr>
-          <a:xfrm>
-            <a:off x="777240" y="5541264"/>
-            <a:ext cx="4929988" cy="219456"/>
-          </a:xfrm>
-          <a:prstGeom prst="rect">
-            <a:avLst/>
-          </a:prstGeom>
-          <a:noFill/>
-          <a:ln/>
-        </p:spPr>
-        <p:txBody>
-          <a:bodyPr wrap="square" lIns="0" tIns="0" rIns="0" bIns="0" rtlCol="0" anchor="ctr"/>
-          <a:lstStyle/>
-          <a:p>
+          <p:cNvPr id="38" name="Text 33"/>
+          <p:cNvSpPr/>
+          <p:nvPr/>
+        </p:nvSpPr>
+        <p:spPr>
+          <a:xfrm>
+            <a:off x="8313725" y="2880360"/>
+            <a:ext cx="3155594" cy="292608"/>
+          </a:xfrm>
+          <a:prstGeom prst="rect">
+            <a:avLst/>
+          </a:prstGeom>
+          <a:noFill/>
+          <a:ln/>
+        </p:spPr>
+        <p:txBody>
+          <a:bodyPr wrap="square" lIns="0" tIns="0" rIns="0" bIns="0" rtlCol="0" anchor="ctr"/>
+          <a:lstStyle/>
+          <a:p>
+            <a:pPr indent="0" marL="0">
+              <a:buNone/>
+            </a:pPr>
+            <a:r>
+              <a:rPr lang="en-US" sz="950" b="1" dirty="0">
+                <a:solidFill>
+                  <a:srgbClr val="0C0C0C"/>
+                </a:solidFill>
+                <a:latin typeface="DM Sans" pitchFamily="34" charset="0"/>
+                <a:ea typeface="DM Sans" pitchFamily="34" charset="-122"/>
+                <a:cs typeface="DM Sans" pitchFamily="34" charset="-120"/>
+              </a:rPr>
+              <a:t>Target state decided</a:t>
+            </a:r>
             <a:pPr indent="0" marL="0">
               <a:buNone/>
             </a:pPr>
@@ -2278,21 +2314,7 @@
                 <a:ea typeface="DM Sans" pitchFamily="34" charset="-122"/>
                 <a:cs typeface="DM Sans" pitchFamily="34" charset="-120"/>
               </a:rPr>
-              <a:t>~$500M tech capital over 5–6 yrs²  ·  builds on GP25 &amp; Helix: </a:t>
-            </a:r>
-            <a:pPr indent="0" marL="0">
-              <a:buNone/>
-            </a:pPr>
-            <a:r>
-              <a:rPr lang="en-US" sz="950" b="1" dirty="0">
-                <a:solidFill>
-                  <a:srgbClr val="0C0C0C"/>
-                </a:solidFill>
-                <a:latin typeface="DM Sans" pitchFamily="34" charset="0"/>
-                <a:ea typeface="DM Sans" pitchFamily="34" charset="-122"/>
-                <a:cs typeface="DM Sans" pitchFamily="34" charset="-120"/>
-              </a:rPr>
-              <a:t>60+ platforms retired</a:t>
+              <a:t> &amp; validated across all functions</a:t>
             </a:r>
             <a:endParaRPr lang="en-US" sz="950" dirty="0"/>
           </a:p>
@@ -2300,14 +2322,14 @@
       </p:sp>
       <p:sp>
         <p:nvSpPr>
-          <p:cNvPr id="38" name="Shape 33"/>
-          <p:cNvSpPr/>
-          <p:nvPr/>
-        </p:nvSpPr>
-        <p:spPr>
-          <a:xfrm>
-            <a:off x="6210148" y="3456432"/>
-            <a:ext cx="5478628" cy="2331720"/>
+          <p:cNvPr id="39" name="Shape 34"/>
+          <p:cNvSpPr/>
+          <p:nvPr/>
+        </p:nvSpPr>
+        <p:spPr>
+          <a:xfrm>
+            <a:off x="502920" y="3456432"/>
+            <a:ext cx="3594506" cy="2331720"/>
           </a:xfrm>
           <a:prstGeom prst="roundRect">
             <a:avLst>
@@ -2322,14 +2344,14 @@
       </p:sp>
       <p:sp>
         <p:nvSpPr>
-          <p:cNvPr id="39" name="Text 34"/>
-          <p:cNvSpPr/>
-          <p:nvPr/>
-        </p:nvSpPr>
-        <p:spPr>
-          <a:xfrm>
-            <a:off x="6484468" y="3639312"/>
-            <a:ext cx="4929988" cy="274320"/>
+          <p:cNvPr id="40" name="Text 35"/>
+          <p:cNvSpPr/>
+          <p:nvPr/>
+        </p:nvSpPr>
+        <p:spPr>
+          <a:xfrm>
+            <a:off x="722376" y="3621024"/>
+            <a:ext cx="3155594" cy="256032"/>
           </a:xfrm>
           <a:prstGeom prst="rect">
             <a:avLst/>
@@ -2345,7 +2367,7 @@
               <a:buNone/>
             </a:pPr>
             <a:r>
-              <a:rPr lang="en-US" sz="1100" b="1" spc="200" kern="0" dirty="0">
+              <a:rPr lang="en-US" sz="1050" b="1" spc="200" kern="0" dirty="0">
                 <a:solidFill>
                   <a:srgbClr val="262AFF"/>
                 </a:solidFill>
@@ -2353,7 +2375,219 @@
                 <a:ea typeface="DM Sans" pitchFamily="34" charset="-122"/>
                 <a:cs typeface="DM Sans" pitchFamily="34" charset="-120"/>
               </a:rPr>
-              <a:t>SIMPLIFICATION FUNDS THE SHIFT TO GROWTH</a:t>
+              <a:t>SIMPLIFY, THEN CONSOLIDATE</a:t>
+            </a:r>
+            <a:endParaRPr lang="en-US" sz="1050" dirty="0"/>
+          </a:p>
+        </p:txBody>
+      </p:sp>
+      <p:sp>
+        <p:nvSpPr>
+          <p:cNvPr id="41" name="Text 36"/>
+          <p:cNvSpPr/>
+          <p:nvPr/>
+        </p:nvSpPr>
+        <p:spPr>
+          <a:xfrm>
+            <a:off x="722376" y="3913632"/>
+            <a:ext cx="1325880" cy="502920"/>
+          </a:xfrm>
+          <a:prstGeom prst="rect">
+            <a:avLst/>
+          </a:prstGeom>
+          <a:noFill/>
+          <a:ln/>
+        </p:spPr>
+        <p:txBody>
+          <a:bodyPr wrap="square" lIns="0" tIns="0" rIns="0" bIns="0" rtlCol="0" anchor="ctr"/>
+          <a:lstStyle/>
+          <a:p>
+            <a:pPr indent="0" marL="0">
+              <a:buNone/>
+            </a:pPr>
+            <a:r>
+              <a:rPr lang="en-US" sz="3200" b="1" dirty="0">
+                <a:solidFill>
+                  <a:srgbClr val="262AFF"/>
+                </a:solidFill>
+                <a:latin typeface="DM Sans" pitchFamily="34" charset="0"/>
+                <a:ea typeface="DM Sans" pitchFamily="34" charset="-122"/>
+                <a:cs typeface="DM Sans" pitchFamily="34" charset="-120"/>
+              </a:rPr>
+              <a:t>&gt;80%</a:t>
+            </a:r>
+            <a:endParaRPr lang="en-US" sz="3200" dirty="0"/>
+          </a:p>
+        </p:txBody>
+      </p:sp>
+      <p:sp>
+        <p:nvSpPr>
+          <p:cNvPr id="42" name="Text 37"/>
+          <p:cNvSpPr/>
+          <p:nvPr/>
+        </p:nvSpPr>
+        <p:spPr>
+          <a:xfrm>
+            <a:off x="2139696" y="3931920"/>
+            <a:ext cx="1738274" cy="475488"/>
+          </a:xfrm>
+          <a:prstGeom prst="rect">
+            <a:avLst/>
+          </a:prstGeom>
+          <a:noFill/>
+          <a:ln/>
+        </p:spPr>
+        <p:txBody>
+          <a:bodyPr wrap="square" lIns="0" tIns="0" rIns="0" bIns="0" rtlCol="0" anchor="ctr"/>
+          <a:lstStyle/>
+          <a:p>
+            <a:pPr indent="0" marL="0">
+              <a:buNone/>
+            </a:pPr>
+            <a:r>
+              <a:rPr lang="en-US" sz="950" dirty="0">
+                <a:solidFill>
+                  <a:srgbClr val="55565B"/>
+                </a:solidFill>
+                <a:latin typeface="DM Sans" pitchFamily="34" charset="0"/>
+                <a:ea typeface="DM Sans" pitchFamily="34" charset="-122"/>
+                <a:cs typeface="DM Sans" pitchFamily="34" charset="-120"/>
+              </a:rPr>
+              <a:t>smaller platform estate,</a:t>
+            </a:r>
+            <a:endParaRPr lang="en-US" sz="950" dirty="0"/>
+          </a:p>
+          <a:p>
+            <a:pPr indent="0" marL="0">
+              <a:buNone/>
+            </a:pPr>
+            <a:r>
+              <a:rPr lang="en-US" sz="950" dirty="0">
+                <a:solidFill>
+                  <a:srgbClr val="55565B"/>
+                </a:solidFill>
+                <a:latin typeface="DM Sans" pitchFamily="34" charset="0"/>
+                <a:ea typeface="DM Sans" pitchFamily="34" charset="-122"/>
+                <a:cs typeface="DM Sans" pitchFamily="34" charset="-120"/>
+              </a:rPr>
+              <a:t>one target state</a:t>
+            </a:r>
+            <a:endParaRPr lang="en-US" sz="950" dirty="0"/>
+          </a:p>
+        </p:txBody>
+      </p:sp>
+      <p:sp>
+        <p:nvSpPr>
+          <p:cNvPr id="43" name="Shape 38"/>
+          <p:cNvSpPr/>
+          <p:nvPr/>
+        </p:nvSpPr>
+        <p:spPr>
+          <a:xfrm>
+            <a:off x="722376" y="4462272"/>
+            <a:ext cx="3155594" cy="530352"/>
+          </a:xfrm>
+          <a:prstGeom prst="roundRect">
+            <a:avLst>
+              <a:gd name="adj" fmla="val 8621"/>
+            </a:avLst>
+          </a:prstGeom>
+          <a:solidFill>
+            <a:srgbClr val="FFFFFF"/>
+          </a:solidFill>
+          <a:ln/>
+        </p:spPr>
+      </p:sp>
+      <p:sp>
+        <p:nvSpPr>
+          <p:cNvPr id="44" name="Text 39"/>
+          <p:cNvSpPr/>
+          <p:nvPr/>
+        </p:nvSpPr>
+        <p:spPr>
+          <a:xfrm>
+            <a:off x="859536" y="4462272"/>
+            <a:ext cx="2917850" cy="530352"/>
+          </a:xfrm>
+          <a:prstGeom prst="rect">
+            <a:avLst/>
+          </a:prstGeom>
+          <a:noFill/>
+          <a:ln/>
+        </p:spPr>
+        <p:txBody>
+          <a:bodyPr wrap="square" lIns="0" tIns="0" rIns="0" bIns="0" rtlCol="0" anchor="ctr"/>
+          <a:lstStyle/>
+          <a:p>
+            <a:pPr indent="0" marL="0">
+              <a:buNone/>
+            </a:pPr>
+            <a:r>
+              <a:rPr lang="en-US" sz="900" b="1" spc="100" kern="0" dirty="0">
+                <a:solidFill>
+                  <a:srgbClr val="262AFF"/>
+                </a:solidFill>
+                <a:latin typeface="DM Sans" pitchFamily="34" charset="0"/>
+                <a:ea typeface="DM Sans" pitchFamily="34" charset="-122"/>
+                <a:cs typeface="DM Sans" pitchFamily="34" charset="-120"/>
+              </a:rPr>
+              <a:t>Y1–2  ·  ~$250M</a:t>
+            </a:r>
+            <a:endParaRPr lang="en-US" sz="900" dirty="0"/>
+          </a:p>
+          <a:p>
+            <a:pPr indent="0" marL="0">
+              <a:buNone/>
+            </a:pPr>
+            <a:r>
+              <a:rPr lang="en-US" sz="1050" b="1" dirty="0">
+                <a:solidFill>
+                  <a:srgbClr val="0C0C0C"/>
+                </a:solidFill>
+                <a:latin typeface="DM Sans" pitchFamily="34" charset="0"/>
+                <a:ea typeface="DM Sans" pitchFamily="34" charset="-122"/>
+                <a:cs typeface="DM Sans" pitchFamily="34" charset="-120"/>
+              </a:rPr>
+              <a:t>Simplify the customer experience</a:t>
+            </a:r>
+            <a:endParaRPr lang="en-US" sz="900" dirty="0"/>
+          </a:p>
+        </p:txBody>
+      </p:sp>
+      <p:sp>
+        <p:nvSpPr>
+          <p:cNvPr id="45" name="Text 40"/>
+          <p:cNvSpPr/>
+          <p:nvPr/>
+        </p:nvSpPr>
+        <p:spPr>
+          <a:xfrm rot="5400000">
+            <a:off x="2163013" y="5001768"/>
+            <a:ext cx="274320" cy="146304"/>
+          </a:xfrm>
+          <a:prstGeom prst="rect">
+            <a:avLst/>
+          </a:prstGeom>
+          <a:noFill/>
+          <a:ln/>
+        </p:spPr>
+        <p:txBody>
+          <a:bodyPr wrap="square" lIns="0" tIns="0" rIns="0" bIns="0" rtlCol="0" anchor="ctr"/>
+          <a:lstStyle/>
+          <a:p>
+            <a:pPr algn="ctr" indent="0" marL="0">
+              <a:buNone/>
+            </a:pPr>
+            <a:r>
+              <a:rPr lang="en-US" sz="1100" b="1" dirty="0">
+                <a:solidFill>
+                  <a:srgbClr val="1CABFF"/>
+                </a:solidFill>
+                <a:latin typeface="DM Sans" pitchFamily="34" charset="0"/>
+                <a:ea typeface="DM Sans" pitchFamily="34" charset="-122"/>
+                <a:cs typeface="DM Sans" pitchFamily="34" charset="-120"/>
+              </a:rPr>
+              <a:t>❯</a:t>
             </a:r>
             <a:endParaRPr lang="en-US" sz="1100" dirty="0"/>
           </a:p>
@@ -2361,30 +2595,52 @@
       </p:sp>
       <p:sp>
         <p:nvSpPr>
-          <p:cNvPr id="40" name="Text 35"/>
-          <p:cNvSpPr/>
-          <p:nvPr/>
-        </p:nvSpPr>
-        <p:spPr>
-          <a:xfrm>
-            <a:off x="6484468" y="4005072"/>
-            <a:ext cx="2377440" cy="685800"/>
-          </a:xfrm>
-          <a:prstGeom prst="rect">
-            <a:avLst/>
-          </a:prstGeom>
-          <a:noFill/>
-          <a:ln/>
-        </p:spPr>
-        <p:txBody>
-          <a:bodyPr wrap="square" lIns="0" tIns="0" rIns="0" bIns="0" rtlCol="0" anchor="ctr"/>
-          <a:lstStyle/>
-          <a:p>
-            <a:pPr indent="0" marL="0">
-              <a:buNone/>
-            </a:pPr>
-            <a:r>
-              <a:rPr lang="en-US" sz="4000" b="1" dirty="0">
+          <p:cNvPr id="46" name="Shape 41"/>
+          <p:cNvSpPr/>
+          <p:nvPr/>
+        </p:nvSpPr>
+        <p:spPr>
+          <a:xfrm>
+            <a:off x="722376" y="5157216"/>
+            <a:ext cx="3155594" cy="530352"/>
+          </a:xfrm>
+          <a:prstGeom prst="roundRect">
+            <a:avLst>
+              <a:gd name="adj" fmla="val 8621"/>
+            </a:avLst>
+          </a:prstGeom>
+          <a:solidFill>
+            <a:srgbClr val="FFFFFF"/>
+          </a:solidFill>
+          <a:ln/>
+        </p:spPr>
+      </p:sp>
+      <p:sp>
+        <p:nvSpPr>
+          <p:cNvPr id="47" name="Text 42"/>
+          <p:cNvSpPr/>
+          <p:nvPr/>
+        </p:nvSpPr>
+        <p:spPr>
+          <a:xfrm>
+            <a:off x="859536" y="5157216"/>
+            <a:ext cx="2917850" cy="530352"/>
+          </a:xfrm>
+          <a:prstGeom prst="rect">
+            <a:avLst/>
+          </a:prstGeom>
+          <a:noFill/>
+          <a:ln/>
+        </p:spPr>
+        <p:txBody>
+          <a:bodyPr wrap="square" lIns="0" tIns="0" rIns="0" bIns="0" rtlCol="0" anchor="ctr"/>
+          <a:lstStyle/>
+          <a:p>
+            <a:pPr indent="0" marL="0">
+              <a:buNone/>
+            </a:pPr>
+            <a:r>
+              <a:rPr lang="en-US" sz="900" b="1" spc="100" kern="0" dirty="0">
                 <a:solidFill>
                   <a:srgbClr val="262AFF"/>
                 </a:solidFill>
@@ -2392,38 +2648,155 @@
                 <a:ea typeface="DM Sans" pitchFamily="34" charset="-122"/>
                 <a:cs typeface="DM Sans" pitchFamily="34" charset="-120"/>
               </a:rPr>
+              <a:t>Y3–5  ·  ~$250M</a:t>
+            </a:r>
+            <a:endParaRPr lang="en-US" sz="900" dirty="0"/>
+          </a:p>
+          <a:p>
+            <a:pPr indent="0" marL="0">
+              <a:buNone/>
+            </a:pPr>
+            <a:r>
+              <a:rPr lang="en-US" sz="1050" b="1" dirty="0">
+                <a:solidFill>
+                  <a:srgbClr val="0C0C0C"/>
+                </a:solidFill>
+                <a:latin typeface="DM Sans" pitchFamily="34" charset="0"/>
+                <a:ea typeface="DM Sans" pitchFamily="34" charset="-122"/>
+                <a:cs typeface="DM Sans" pitchFamily="34" charset="-120"/>
+              </a:rPr>
+              <a:t>Consolidate the back-ends</a:t>
+            </a:r>
+            <a:endParaRPr lang="en-US" sz="900" dirty="0"/>
+          </a:p>
+        </p:txBody>
+      </p:sp>
+      <p:sp>
+        <p:nvSpPr>
+          <p:cNvPr id="48" name="Shape 43"/>
+          <p:cNvSpPr/>
+          <p:nvPr/>
+        </p:nvSpPr>
+        <p:spPr>
+          <a:xfrm>
+            <a:off x="4298594" y="3456432"/>
+            <a:ext cx="3594506" cy="2331720"/>
+          </a:xfrm>
+          <a:prstGeom prst="roundRect">
+            <a:avLst>
+              <a:gd name="adj" fmla="val 3137"/>
+            </a:avLst>
+          </a:prstGeom>
+          <a:solidFill>
+            <a:srgbClr val="E9E9FC"/>
+          </a:solidFill>
+          <a:ln/>
+        </p:spPr>
+      </p:sp>
+      <p:sp>
+        <p:nvSpPr>
+          <p:cNvPr id="49" name="Text 44"/>
+          <p:cNvSpPr/>
+          <p:nvPr/>
+        </p:nvSpPr>
+        <p:spPr>
+          <a:xfrm>
+            <a:off x="4518050" y="3621024"/>
+            <a:ext cx="3155594" cy="256032"/>
+          </a:xfrm>
+          <a:prstGeom prst="rect">
+            <a:avLst/>
+          </a:prstGeom>
+          <a:noFill/>
+          <a:ln/>
+        </p:spPr>
+        <p:txBody>
+          <a:bodyPr wrap="square" lIns="0" tIns="0" rIns="0" bIns="0" rtlCol="0" anchor="ctr"/>
+          <a:lstStyle/>
+          <a:p>
+            <a:pPr algn="l" indent="0" marL="0">
+              <a:buNone/>
+            </a:pPr>
+            <a:r>
+              <a:rPr lang="en-US" sz="1050" b="1" spc="200" kern="0" dirty="0">
+                <a:solidFill>
+                  <a:srgbClr val="262AFF"/>
+                </a:solidFill>
+                <a:latin typeface="DM Sans" pitchFamily="34" charset="0"/>
+                <a:ea typeface="DM Sans" pitchFamily="34" charset="-122"/>
+                <a:cs typeface="DM Sans" pitchFamily="34" charset="-120"/>
+              </a:rPr>
+              <a:t>SIMPLIFICATION FUNDS GROWTH</a:t>
+            </a:r>
+            <a:endParaRPr lang="en-US" sz="1050" dirty="0"/>
+          </a:p>
+        </p:txBody>
+      </p:sp>
+      <p:sp>
+        <p:nvSpPr>
+          <p:cNvPr id="50" name="Text 45"/>
+          <p:cNvSpPr/>
+          <p:nvPr/>
+        </p:nvSpPr>
+        <p:spPr>
+          <a:xfrm>
+            <a:off x="4518050" y="3913632"/>
+            <a:ext cx="2011680" cy="502920"/>
+          </a:xfrm>
+          <a:prstGeom prst="rect">
+            <a:avLst/>
+          </a:prstGeom>
+          <a:noFill/>
+          <a:ln/>
+        </p:spPr>
+        <p:txBody>
+          <a:bodyPr wrap="square" lIns="0" tIns="0" rIns="0" bIns="0" rtlCol="0" anchor="ctr"/>
+          <a:lstStyle/>
+          <a:p>
+            <a:pPr indent="0" marL="0">
+              <a:buNone/>
+            </a:pPr>
+            <a:r>
+              <a:rPr lang="en-US" sz="3200" b="1" dirty="0">
+                <a:solidFill>
+                  <a:srgbClr val="262AFF"/>
+                </a:solidFill>
+                <a:latin typeface="DM Sans" pitchFamily="34" charset="0"/>
+                <a:ea typeface="DM Sans" pitchFamily="34" charset="-122"/>
+                <a:cs typeface="DM Sans" pitchFamily="34" charset="-120"/>
+              </a:rPr>
               <a:t>$200M+</a:t>
             </a:r>
-            <a:endParaRPr lang="en-US" sz="4000" dirty="0"/>
-          </a:p>
-        </p:txBody>
-      </p:sp>
-      <p:sp>
-        <p:nvSpPr>
-          <p:cNvPr id="41" name="Text 36"/>
-          <p:cNvSpPr/>
-          <p:nvPr/>
-        </p:nvSpPr>
-        <p:spPr>
-          <a:xfrm>
-            <a:off x="6484468" y="4663440"/>
-            <a:ext cx="2194560" cy="548640"/>
-          </a:xfrm>
-          <a:prstGeom prst="rect">
-            <a:avLst/>
-          </a:prstGeom>
-          <a:noFill/>
-          <a:ln/>
-        </p:spPr>
-        <p:txBody>
-          <a:bodyPr wrap="square" lIns="0" tIns="0" rIns="0" bIns="0" rtlCol="0" anchor="ctr"/>
-          <a:lstStyle/>
-          <a:p>
-            <a:pPr indent="0" marL="0">
-              <a:buNone/>
-            </a:pPr>
-            <a:r>
-              <a:rPr lang="en-US" sz="1100" dirty="0">
+            <a:endParaRPr lang="en-US" sz="3200" dirty="0"/>
+          </a:p>
+        </p:txBody>
+      </p:sp>
+      <p:sp>
+        <p:nvSpPr>
+          <p:cNvPr id="51" name="Text 46"/>
+          <p:cNvSpPr/>
+          <p:nvPr/>
+        </p:nvSpPr>
+        <p:spPr>
+          <a:xfrm>
+            <a:off x="4518050" y="4416552"/>
+            <a:ext cx="3155594" cy="201168"/>
+          </a:xfrm>
+          <a:prstGeom prst="rect">
+            <a:avLst/>
+          </a:prstGeom>
+          <a:noFill/>
+          <a:ln/>
+        </p:spPr>
+        <p:txBody>
+          <a:bodyPr wrap="square" lIns="0" tIns="0" rIns="0" bIns="0" rtlCol="0" anchor="ctr"/>
+          <a:lstStyle/>
+          <a:p>
+            <a:pPr indent="0" marL="0">
+              <a:buNone/>
+            </a:pPr>
+            <a:r>
+              <a:rPr lang="en-US" sz="950" dirty="0">
                 <a:solidFill>
                   <a:srgbClr val="55565B"/>
                 </a:solidFill>
@@ -2431,39 +2804,22 @@
                 <a:ea typeface="DM Sans" pitchFamily="34" charset="-122"/>
                 <a:cs typeface="DM Sans" pitchFamily="34" charset="-120"/>
               </a:rPr>
-              <a:t>opex unlock over 5 years,</a:t>
-            </a:r>
-            <a:endParaRPr lang="en-US" sz="1100" dirty="0"/>
-          </a:p>
-          <a:p>
-            <a:pPr indent="0" marL="0">
-              <a:buNone/>
-            </a:pPr>
-            <a:r>
-              <a:rPr lang="en-US" sz="1100" dirty="0">
-                <a:solidFill>
-                  <a:srgbClr val="55565B"/>
-                </a:solidFill>
-                <a:latin typeface="DM Sans" pitchFamily="34" charset="0"/>
-                <a:ea typeface="DM Sans" pitchFamily="34" charset="-122"/>
-                <a:cs typeface="DM Sans" pitchFamily="34" charset="-120"/>
-              </a:rPr>
-              <a:t>already committed</a:t>
-            </a:r>
-            <a:endParaRPr lang="en-US" sz="1100" dirty="0"/>
-          </a:p>
-        </p:txBody>
-      </p:sp>
-      <p:sp>
-        <p:nvSpPr>
-          <p:cNvPr id="42" name="Shape 37"/>
-          <p:cNvSpPr/>
-          <p:nvPr/>
-        </p:nvSpPr>
-        <p:spPr>
-          <a:xfrm>
-            <a:off x="8953348" y="3986784"/>
-            <a:ext cx="365760" cy="365760"/>
+              <a:t>opex unlock over 5 years — committed</a:t>
+            </a:r>
+            <a:endParaRPr lang="en-US" sz="950" dirty="0"/>
+          </a:p>
+        </p:txBody>
+      </p:sp>
+      <p:sp>
+        <p:nvSpPr>
+          <p:cNvPr id="52" name="Shape 47"/>
+          <p:cNvSpPr/>
+          <p:nvPr/>
+        </p:nvSpPr>
+        <p:spPr>
+          <a:xfrm>
+            <a:off x="4518050" y="4809744"/>
+            <a:ext cx="274320" cy="274320"/>
           </a:xfrm>
           <a:prstGeom prst="ellipse">
             <a:avLst/>
@@ -2476,7 +2832,7 @@
       </p:sp>
       <p:pic>
         <p:nvPicPr>
-          <p:cNvPr id="43" name="Image 3" descr="icons_hi/icon101.png">    </p:cNvPr>
+          <p:cNvPr id="53" name="Image 3" descr="icons_hi/icon101.png">    </p:cNvPr>
           <p:cNvPicPr>
             <a:picLocks noChangeAspect="1"/>
           </p:cNvPicPr>
@@ -2490,8 +2846,8 @@
         </p:blipFill>
         <p:spPr>
           <a:xfrm>
-            <a:off x="9033815" y="4067251"/>
-            <a:ext cx="204826" cy="204826"/>
+            <a:off x="4578401" y="4870094"/>
+            <a:ext cx="153619" cy="153619"/>
           </a:xfrm>
           <a:prstGeom prst="rect">
             <a:avLst/>
@@ -2500,30 +2856,30 @@
       </p:pic>
       <p:sp>
         <p:nvSpPr>
-          <p:cNvPr id="44" name="Text 38"/>
-          <p:cNvSpPr/>
-          <p:nvPr/>
-        </p:nvSpPr>
-        <p:spPr>
-          <a:xfrm>
-            <a:off x="9428836" y="3931920"/>
-            <a:ext cx="2003908" cy="475488"/>
-          </a:xfrm>
-          <a:prstGeom prst="rect">
-            <a:avLst/>
-          </a:prstGeom>
-          <a:noFill/>
-          <a:ln/>
-        </p:spPr>
-        <p:txBody>
-          <a:bodyPr wrap="square" lIns="0" tIns="0" rIns="0" bIns="0" rtlCol="0" anchor="ctr"/>
-          <a:lstStyle/>
-          <a:p>
-            <a:pPr indent="0" marL="0">
-              <a:buNone/>
-            </a:pPr>
-            <a:r>
-              <a:rPr lang="en-US" sz="1150" b="1" dirty="0">
+          <p:cNvPr id="54" name="Text 48"/>
+          <p:cNvSpPr/>
+          <p:nvPr/>
+        </p:nvSpPr>
+        <p:spPr>
+          <a:xfrm>
+            <a:off x="4902098" y="4764024"/>
+            <a:ext cx="2771546" cy="365760"/>
+          </a:xfrm>
+          <a:prstGeom prst="rect">
+            <a:avLst/>
+          </a:prstGeom>
+          <a:noFill/>
+          <a:ln/>
+        </p:spPr>
+        <p:txBody>
+          <a:bodyPr wrap="square" lIns="0" tIns="0" rIns="0" bIns="0" rtlCol="0" anchor="ctr"/>
+          <a:lstStyle/>
+          <a:p>
+            <a:pPr indent="0" marL="0">
+              <a:buNone/>
+            </a:pPr>
+            <a:r>
+              <a:rPr lang="en-US" sz="1050" b="1" dirty="0">
                 <a:solidFill>
                   <a:srgbClr val="262AFF"/>
                 </a:solidFill>
@@ -2537,7 +2893,7 @@
               <a:buNone/>
             </a:pPr>
             <a:r>
-              <a:rPr lang="en-US" sz="1150" dirty="0">
+              <a:rPr lang="en-US" sz="1050" dirty="0">
                 <a:solidFill>
                   <a:srgbClr val="55565B"/>
                 </a:solidFill>
@@ -2545,22 +2901,22 @@
                 <a:ea typeface="DM Sans" pitchFamily="34" charset="-122"/>
                 <a:cs typeface="DM Sans" pitchFamily="34" charset="-120"/>
               </a:rPr>
-              <a:t> new markets &amp; segments at lower cost</a:t>
-            </a:r>
-            <a:endParaRPr lang="en-US" sz="1150" dirty="0"/>
-          </a:p>
-        </p:txBody>
-      </p:sp>
-      <p:sp>
-        <p:nvSpPr>
-          <p:cNvPr id="45" name="Shape 39"/>
-          <p:cNvSpPr/>
-          <p:nvPr/>
-        </p:nvSpPr>
-        <p:spPr>
-          <a:xfrm>
-            <a:off x="8953348" y="4462272"/>
-            <a:ext cx="365760" cy="365760"/>
+              <a:t> new markets at lower cost</a:t>
+            </a:r>
+            <a:endParaRPr lang="en-US" sz="1050" dirty="0"/>
+          </a:p>
+        </p:txBody>
+      </p:sp>
+      <p:sp>
+        <p:nvSpPr>
+          <p:cNvPr id="55" name="Shape 49"/>
+          <p:cNvSpPr/>
+          <p:nvPr/>
+        </p:nvSpPr>
+        <p:spPr>
+          <a:xfrm>
+            <a:off x="4518050" y="5138928"/>
+            <a:ext cx="274320" cy="274320"/>
           </a:xfrm>
           <a:prstGeom prst="ellipse">
             <a:avLst/>
@@ -2573,7 +2929,7 @@
       </p:sp>
       <p:pic>
         <p:nvPicPr>
-          <p:cNvPr id="46" name="Image 4" descr="icons_hi/icon52.png">    </p:cNvPr>
+          <p:cNvPr id="56" name="Image 4" descr="icons_hi/icon52.png">    </p:cNvPr>
           <p:cNvPicPr>
             <a:picLocks noChangeAspect="1"/>
           </p:cNvPicPr>
@@ -2587,8 +2943,8 @@
         </p:blipFill>
         <p:spPr>
           <a:xfrm>
-            <a:off x="9033815" y="4542739"/>
-            <a:ext cx="204826" cy="204826"/>
+            <a:off x="4578401" y="5199278"/>
+            <a:ext cx="153619" cy="153619"/>
           </a:xfrm>
           <a:prstGeom prst="rect">
             <a:avLst/>
@@ -2597,30 +2953,30 @@
       </p:pic>
       <p:sp>
         <p:nvSpPr>
-          <p:cNvPr id="47" name="Text 40"/>
-          <p:cNvSpPr/>
-          <p:nvPr/>
-        </p:nvSpPr>
-        <p:spPr>
-          <a:xfrm>
-            <a:off x="9428836" y="4407408"/>
-            <a:ext cx="2003908" cy="475488"/>
-          </a:xfrm>
-          <a:prstGeom prst="rect">
-            <a:avLst/>
-          </a:prstGeom>
-          <a:noFill/>
-          <a:ln/>
-        </p:spPr>
-        <p:txBody>
-          <a:bodyPr wrap="square" lIns="0" tIns="0" rIns="0" bIns="0" rtlCol="0" anchor="ctr"/>
-          <a:lstStyle/>
-          <a:p>
-            <a:pPr indent="0" marL="0">
-              <a:buNone/>
-            </a:pPr>
-            <a:r>
-              <a:rPr lang="en-US" sz="1150" b="1" dirty="0">
+          <p:cNvPr id="57" name="Text 50"/>
+          <p:cNvSpPr/>
+          <p:nvPr/>
+        </p:nvSpPr>
+        <p:spPr>
+          <a:xfrm>
+            <a:off x="4902098" y="5093208"/>
+            <a:ext cx="2771546" cy="365760"/>
+          </a:xfrm>
+          <a:prstGeom prst="rect">
+            <a:avLst/>
+          </a:prstGeom>
+          <a:noFill/>
+          <a:ln/>
+        </p:spPr>
+        <p:txBody>
+          <a:bodyPr wrap="square" lIns="0" tIns="0" rIns="0" bIns="0" rtlCol="0" anchor="ctr"/>
+          <a:lstStyle/>
+          <a:p>
+            <a:pPr indent="0" marL="0">
+              <a:buNone/>
+            </a:pPr>
+            <a:r>
+              <a:rPr lang="en-US" sz="1050" b="1" dirty="0">
                 <a:solidFill>
                   <a:srgbClr val="262AFF"/>
                 </a:solidFill>
@@ -2634,7 +2990,7 @@
               <a:buNone/>
             </a:pPr>
             <a:r>
-              <a:rPr lang="en-US" sz="1150" dirty="0">
+              <a:rPr lang="en-US" sz="1050" dirty="0">
                 <a:solidFill>
                   <a:srgbClr val="55565B"/>
                 </a:solidFill>
@@ -2642,22 +2998,22 @@
                 <a:ea typeface="DM Sans" pitchFamily="34" charset="-122"/>
                 <a:cs typeface="DM Sans" pitchFamily="34" charset="-120"/>
               </a:rPr>
-              <a:t> more of the demand GP competes for</a:t>
-            </a:r>
-            <a:endParaRPr lang="en-US" sz="1150" dirty="0"/>
-          </a:p>
-        </p:txBody>
-      </p:sp>
-      <p:sp>
-        <p:nvSpPr>
-          <p:cNvPr id="48" name="Shape 41"/>
-          <p:cNvSpPr/>
-          <p:nvPr/>
-        </p:nvSpPr>
-        <p:spPr>
-          <a:xfrm>
-            <a:off x="8953348" y="4937760"/>
-            <a:ext cx="365760" cy="365760"/>
+              <a:t> more of today’s demand</a:t>
+            </a:r>
+            <a:endParaRPr lang="en-US" sz="1050" dirty="0"/>
+          </a:p>
+        </p:txBody>
+      </p:sp>
+      <p:sp>
+        <p:nvSpPr>
+          <p:cNvPr id="58" name="Shape 51"/>
+          <p:cNvSpPr/>
+          <p:nvPr/>
+        </p:nvSpPr>
+        <p:spPr>
+          <a:xfrm>
+            <a:off x="4518050" y="5468112"/>
+            <a:ext cx="274320" cy="274320"/>
           </a:xfrm>
           <a:prstGeom prst="ellipse">
             <a:avLst/>
@@ -2670,7 +3026,7 @@
       </p:sp>
       <p:pic>
         <p:nvPicPr>
-          <p:cNvPr id="49" name="Image 5" descr="icons_hi/icon93.png">    </p:cNvPr>
+          <p:cNvPr id="59" name="Image 5" descr="icons_hi/icon93.png">    </p:cNvPr>
           <p:cNvPicPr>
             <a:picLocks noChangeAspect="1"/>
           </p:cNvPicPr>
@@ -2684,8 +3040,8 @@
         </p:blipFill>
         <p:spPr>
           <a:xfrm>
-            <a:off x="9033815" y="5018227"/>
-            <a:ext cx="204826" cy="204826"/>
+            <a:off x="4578401" y="5528462"/>
+            <a:ext cx="153619" cy="153619"/>
           </a:xfrm>
           <a:prstGeom prst="rect">
             <a:avLst/>
@@ -2694,30 +3050,30 @@
       </p:pic>
       <p:sp>
         <p:nvSpPr>
-          <p:cNvPr id="50" name="Text 42"/>
-          <p:cNvSpPr/>
-          <p:nvPr/>
-        </p:nvSpPr>
-        <p:spPr>
-          <a:xfrm>
-            <a:off x="9428836" y="4882896"/>
-            <a:ext cx="2003908" cy="475488"/>
-          </a:xfrm>
-          <a:prstGeom prst="rect">
-            <a:avLst/>
-          </a:prstGeom>
-          <a:noFill/>
-          <a:ln/>
-        </p:spPr>
-        <p:txBody>
-          <a:bodyPr wrap="square" lIns="0" tIns="0" rIns="0" bIns="0" rtlCol="0" anchor="ctr"/>
-          <a:lstStyle/>
-          <a:p>
-            <a:pPr indent="0" marL="0">
-              <a:buNone/>
-            </a:pPr>
-            <a:r>
-              <a:rPr lang="en-US" sz="1150" b="1" dirty="0">
+          <p:cNvPr id="60" name="Text 52"/>
+          <p:cNvSpPr/>
+          <p:nvPr/>
+        </p:nvSpPr>
+        <p:spPr>
+          <a:xfrm>
+            <a:off x="4902098" y="5422392"/>
+            <a:ext cx="2771546" cy="365760"/>
+          </a:xfrm>
+          <a:prstGeom prst="rect">
+            <a:avLst/>
+          </a:prstGeom>
+          <a:noFill/>
+          <a:ln/>
+        </p:spPr>
+        <p:txBody>
+          <a:bodyPr wrap="square" lIns="0" tIns="0" rIns="0" bIns="0" rtlCol="0" anchor="ctr"/>
+          <a:lstStyle/>
+          <a:p>
+            <a:pPr indent="0" marL="0">
+              <a:buNone/>
+            </a:pPr>
+            <a:r>
+              <a:rPr lang="en-US" sz="1050" b="1" dirty="0">
                 <a:solidFill>
                   <a:srgbClr val="262AFF"/>
                 </a:solidFill>
@@ -2731,7 +3087,7 @@
               <a:buNone/>
             </a:pPr>
             <a:r>
-              <a:rPr lang="en-US" sz="1150" dirty="0">
+              <a:rPr lang="en-US" sz="1050" dirty="0">
                 <a:solidFill>
                   <a:srgbClr val="55565B"/>
                 </a:solidFill>
@@ -2741,59 +3097,173 @@
               </a:rPr>
               <a:t> every merchant sold</a:t>
             </a:r>
-            <a:endParaRPr lang="en-US" sz="1150" dirty="0"/>
-          </a:p>
-        </p:txBody>
-      </p:sp>
-      <p:sp>
-        <p:nvSpPr>
-          <p:cNvPr id="51" name="Shape 43"/>
-          <p:cNvSpPr/>
-          <p:nvPr/>
-        </p:nvSpPr>
-        <p:spPr>
-          <a:xfrm>
-            <a:off x="6484468" y="5449824"/>
-            <a:ext cx="4929988" cy="0"/>
-          </a:xfrm>
-          <a:prstGeom prst="line">
-            <a:avLst/>
-          </a:prstGeom>
-          <a:noFill/>
-          <a:ln w="9525">
-            <a:solidFill>
-              <a:srgbClr val="CFCFF5"/>
-            </a:solidFill>
-            <a:prstDash val="solid"/>
-          </a:ln>
-        </p:spPr>
-      </p:sp>
-      <p:sp>
-        <p:nvSpPr>
-          <p:cNvPr id="52" name="Text 44"/>
-          <p:cNvSpPr/>
-          <p:nvPr/>
-        </p:nvSpPr>
-        <p:spPr>
-          <a:xfrm>
-            <a:off x="6484468" y="5486400"/>
-            <a:ext cx="4929988" cy="274320"/>
-          </a:xfrm>
-          <a:prstGeom prst="rect">
-            <a:avLst/>
-          </a:prstGeom>
-          <a:noFill/>
-          <a:ln/>
-        </p:spPr>
-        <p:txBody>
-          <a:bodyPr wrap="square" lIns="0" tIns="0" rIns="0" bIns="0" rtlCol="0" anchor="ctr"/>
-          <a:lstStyle/>
-          <a:p>
-            <a:pPr indent="0" marL="0">
-              <a:buNone/>
-            </a:pPr>
-            <a:r>
-              <a:rPr lang="en-US" sz="1050" dirty="0">
+            <a:endParaRPr lang="en-US" sz="1050" dirty="0"/>
+          </a:p>
+        </p:txBody>
+      </p:sp>
+      <p:sp>
+        <p:nvSpPr>
+          <p:cNvPr id="61" name="Shape 53"/>
+          <p:cNvSpPr/>
+          <p:nvPr/>
+        </p:nvSpPr>
+        <p:spPr>
+          <a:xfrm>
+            <a:off x="8094269" y="3456432"/>
+            <a:ext cx="3594506" cy="2331720"/>
+          </a:xfrm>
+          <a:prstGeom prst="roundRect">
+            <a:avLst>
+              <a:gd name="adj" fmla="val 3137"/>
+            </a:avLst>
+          </a:prstGeom>
+          <a:solidFill>
+            <a:srgbClr val="E9E9FC"/>
+          </a:solidFill>
+          <a:ln/>
+        </p:spPr>
+      </p:sp>
+      <p:sp>
+        <p:nvSpPr>
+          <p:cNvPr id="62" name="Text 54"/>
+          <p:cNvSpPr/>
+          <p:nvPr/>
+        </p:nvSpPr>
+        <p:spPr>
+          <a:xfrm>
+            <a:off x="8313725" y="3621024"/>
+            <a:ext cx="3155594" cy="256032"/>
+          </a:xfrm>
+          <a:prstGeom prst="rect">
+            <a:avLst/>
+          </a:prstGeom>
+          <a:noFill/>
+          <a:ln/>
+        </p:spPr>
+        <p:txBody>
+          <a:bodyPr wrap="square" lIns="0" tIns="0" rIns="0" bIns="0" rtlCol="0" anchor="ctr"/>
+          <a:lstStyle/>
+          <a:p>
+            <a:pPr algn="l" indent="0" marL="0">
+              <a:buNone/>
+            </a:pPr>
+            <a:r>
+              <a:rPr lang="en-US" sz="1050" b="1" spc="200" kern="0" dirty="0">
+                <a:solidFill>
+                  <a:srgbClr val="262AFF"/>
+                </a:solidFill>
+                <a:latin typeface="DM Sans" pitchFamily="34" charset="0"/>
+                <a:ea typeface="DM Sans" pitchFamily="34" charset="-122"/>
+                <a:cs typeface="DM Sans" pitchFamily="34" charset="-120"/>
+              </a:rPr>
+              <a:t>NEXT: AN EXECUTION-READY PLAN</a:t>
+            </a:r>
+            <a:endParaRPr lang="en-US" sz="1050" dirty="0"/>
+          </a:p>
+        </p:txBody>
+      </p:sp>
+      <p:sp>
+        <p:nvSpPr>
+          <p:cNvPr id="63" name="Shape 55"/>
+          <p:cNvSpPr/>
+          <p:nvPr/>
+        </p:nvSpPr>
+        <p:spPr>
+          <a:xfrm>
+            <a:off x="8313725" y="3968496"/>
+            <a:ext cx="310896" cy="310896"/>
+          </a:xfrm>
+          <a:prstGeom prst="ellipse">
+            <a:avLst/>
+          </a:prstGeom>
+          <a:solidFill>
+            <a:srgbClr val="262AFF"/>
+          </a:solidFill>
+          <a:ln/>
+        </p:spPr>
+      </p:sp>
+      <p:sp>
+        <p:nvSpPr>
+          <p:cNvPr id="64" name="Text 56"/>
+          <p:cNvSpPr/>
+          <p:nvPr/>
+        </p:nvSpPr>
+        <p:spPr>
+          <a:xfrm>
+            <a:off x="8313725" y="3968496"/>
+            <a:ext cx="310896" cy="310896"/>
+          </a:xfrm>
+          <a:prstGeom prst="rect">
+            <a:avLst/>
+          </a:prstGeom>
+          <a:noFill/>
+          <a:ln/>
+        </p:spPr>
+        <p:txBody>
+          <a:bodyPr wrap="square" lIns="0" tIns="0" rIns="0" bIns="0" rtlCol="0" anchor="ctr"/>
+          <a:lstStyle/>
+          <a:p>
+            <a:pPr algn="ctr" indent="0" marL="0">
+              <a:buNone/>
+            </a:pPr>
+            <a:r>
+              <a:rPr lang="en-US" sz="1200" b="1" dirty="0">
+                <a:solidFill>
+                  <a:srgbClr val="FFFFFF"/>
+                </a:solidFill>
+                <a:latin typeface="DM Sans" pitchFamily="34" charset="0"/>
+                <a:ea typeface="DM Sans" pitchFamily="34" charset="-122"/>
+                <a:cs typeface="DM Sans" pitchFamily="34" charset="-120"/>
+              </a:rPr>
+              <a:t>1</a:t>
+            </a:r>
+            <a:endParaRPr lang="en-US" sz="1200" dirty="0"/>
+          </a:p>
+        </p:txBody>
+      </p:sp>
+      <p:sp>
+        <p:nvSpPr>
+          <p:cNvPr id="65" name="Text 57"/>
+          <p:cNvSpPr/>
+          <p:nvPr/>
+        </p:nvSpPr>
+        <p:spPr>
+          <a:xfrm>
+            <a:off x="8752637" y="3886200"/>
+            <a:ext cx="2716682" cy="548640"/>
+          </a:xfrm>
+          <a:prstGeom prst="rect">
+            <a:avLst/>
+          </a:prstGeom>
+          <a:noFill/>
+          <a:ln/>
+        </p:spPr>
+        <p:txBody>
+          <a:bodyPr wrap="square" lIns="0" tIns="0" rIns="0" bIns="0" rtlCol="0" anchor="ctr"/>
+          <a:lstStyle/>
+          <a:p>
+            <a:pPr indent="0" marL="0">
+              <a:buNone/>
+            </a:pPr>
+            <a:r>
+              <a:rPr lang="en-US" sz="1100" b="1" dirty="0">
+                <a:solidFill>
+                  <a:srgbClr val="0C0C0C"/>
+                </a:solidFill>
+                <a:latin typeface="DM Sans" pitchFamily="34" charset="0"/>
+                <a:ea typeface="DM Sans" pitchFamily="34" charset="-122"/>
+                <a:cs typeface="DM Sans" pitchFamily="34" charset="-120"/>
+              </a:rPr>
+              <a:t>Sequence the platforms</a:t>
+            </a:r>
+            <a:endParaRPr lang="en-US" sz="1100" dirty="0"/>
+          </a:p>
+          <a:p>
+            <a:pPr indent="0" marL="0">
+              <a:buNone/>
+            </a:pPr>
+            <a:r>
+              <a:rPr lang="en-US" sz="950" dirty="0">
                 <a:solidFill>
                   <a:srgbClr val="55565B"/>
                 </a:solidFill>
@@ -2801,27 +3271,114 @@
                 <a:ea typeface="DM Sans" pitchFamily="34" charset="-122"/>
                 <a:cs typeface="DM Sans" pitchFamily="34" charset="-120"/>
               </a:rPr>
-              <a:t>Tech spend  </a:t>
-            </a:r>
-            <a:pPr indent="0" marL="0">
-              <a:buNone/>
-            </a:pPr>
-            <a:r>
-              <a:rPr lang="en-US" sz="1300" b="1" dirty="0">
-                <a:solidFill>
-                  <a:srgbClr val="262AFF"/>
-                </a:solidFill>
-                <a:latin typeface="DM Sans" pitchFamily="34" charset="0"/>
-                <a:ea typeface="DM Sans" pitchFamily="34" charset="-122"/>
-                <a:cs typeface="DM Sans" pitchFamily="34" charset="-120"/>
-              </a:rPr>
-              <a:t>~10% → ~8%</a:t>
-            </a:r>
-            <a:pPr indent="0" marL="0">
-              <a:buNone/>
-            </a:pPr>
-            <a:r>
-              <a:rPr lang="en-US" sz="1050" dirty="0">
+              <a:t>prioritized by value delivered</a:t>
+            </a:r>
+            <a:endParaRPr lang="en-US" sz="1100" dirty="0"/>
+          </a:p>
+        </p:txBody>
+      </p:sp>
+      <p:sp>
+        <p:nvSpPr>
+          <p:cNvPr id="66" name="Shape 58"/>
+          <p:cNvSpPr/>
+          <p:nvPr/>
+        </p:nvSpPr>
+        <p:spPr>
+          <a:xfrm>
+            <a:off x="8313725" y="4553712"/>
+            <a:ext cx="310896" cy="310896"/>
+          </a:xfrm>
+          <a:prstGeom prst="ellipse">
+            <a:avLst/>
+          </a:prstGeom>
+          <a:solidFill>
+            <a:srgbClr val="262AFF"/>
+          </a:solidFill>
+          <a:ln/>
+        </p:spPr>
+      </p:sp>
+      <p:sp>
+        <p:nvSpPr>
+          <p:cNvPr id="67" name="Text 59"/>
+          <p:cNvSpPr/>
+          <p:nvPr/>
+        </p:nvSpPr>
+        <p:spPr>
+          <a:xfrm>
+            <a:off x="8313725" y="4553712"/>
+            <a:ext cx="310896" cy="310896"/>
+          </a:xfrm>
+          <a:prstGeom prst="rect">
+            <a:avLst/>
+          </a:prstGeom>
+          <a:noFill/>
+          <a:ln/>
+        </p:spPr>
+        <p:txBody>
+          <a:bodyPr wrap="square" lIns="0" tIns="0" rIns="0" bIns="0" rtlCol="0" anchor="ctr"/>
+          <a:lstStyle/>
+          <a:p>
+            <a:pPr algn="ctr" indent="0" marL="0">
+              <a:buNone/>
+            </a:pPr>
+            <a:r>
+              <a:rPr lang="en-US" sz="1200" b="1" dirty="0">
+                <a:solidFill>
+                  <a:srgbClr val="FFFFFF"/>
+                </a:solidFill>
+                <a:latin typeface="DM Sans" pitchFamily="34" charset="0"/>
+                <a:ea typeface="DM Sans" pitchFamily="34" charset="-122"/>
+                <a:cs typeface="DM Sans" pitchFamily="34" charset="-120"/>
+              </a:rPr>
+              <a:t>2</a:t>
+            </a:r>
+            <a:endParaRPr lang="en-US" sz="1200" dirty="0"/>
+          </a:p>
+        </p:txBody>
+      </p:sp>
+      <p:sp>
+        <p:nvSpPr>
+          <p:cNvPr id="68" name="Text 60"/>
+          <p:cNvSpPr/>
+          <p:nvPr/>
+        </p:nvSpPr>
+        <p:spPr>
+          <a:xfrm>
+            <a:off x="8752637" y="4471416"/>
+            <a:ext cx="2716682" cy="548640"/>
+          </a:xfrm>
+          <a:prstGeom prst="rect">
+            <a:avLst/>
+          </a:prstGeom>
+          <a:noFill/>
+          <a:ln/>
+        </p:spPr>
+        <p:txBody>
+          <a:bodyPr wrap="square" lIns="0" tIns="0" rIns="0" bIns="0" rtlCol="0" anchor="ctr"/>
+          <a:lstStyle/>
+          <a:p>
+            <a:pPr indent="0" marL="0">
+              <a:buNone/>
+            </a:pPr>
+            <a:r>
+              <a:rPr lang="en-US" sz="1100" b="1" dirty="0">
+                <a:solidFill>
+                  <a:srgbClr val="0C0C0C"/>
+                </a:solidFill>
+                <a:latin typeface="DM Sans" pitchFamily="34" charset="0"/>
+                <a:ea typeface="DM Sans" pitchFamily="34" charset="-122"/>
+                <a:cs typeface="DM Sans" pitchFamily="34" charset="-120"/>
+              </a:rPr>
+              <a:t>Harden the financials</a:t>
+            </a:r>
+            <a:endParaRPr lang="en-US" sz="1100" dirty="0"/>
+          </a:p>
+          <a:p>
+            <a:pPr indent="0" marL="0">
+              <a:buNone/>
+            </a:pPr>
+            <a:r>
+              <a:rPr lang="en-US" sz="950" dirty="0">
                 <a:solidFill>
                   <a:srgbClr val="55565B"/>
                 </a:solidFill>
@@ -2829,15 +3386,130 @@
                 <a:ea typeface="DM Sans" pitchFamily="34" charset="-122"/>
                 <a:cs typeface="DM Sans" pitchFamily="34" charset="-120"/>
               </a:rPr>
-              <a:t>  of revenue, with KTLO capacity shifted to growth</a:t>
-            </a:r>
-            <a:endParaRPr lang="en-US" sz="1050" dirty="0"/>
-          </a:p>
-        </p:txBody>
-      </p:sp>
-      <p:sp>
-        <p:nvSpPr>
-          <p:cNvPr id="53" name="Shape 45"/>
+              <a:t>up to ~$500M³; ~$200–250M in Y1–2</a:t>
+            </a:r>
+            <a:endParaRPr lang="en-US" sz="1100" dirty="0"/>
+          </a:p>
+        </p:txBody>
+      </p:sp>
+      <p:sp>
+        <p:nvSpPr>
+          <p:cNvPr id="69" name="Shape 61"/>
+          <p:cNvSpPr/>
+          <p:nvPr/>
+        </p:nvSpPr>
+        <p:spPr>
+          <a:xfrm>
+            <a:off x="8313725" y="5138928"/>
+            <a:ext cx="310896" cy="310896"/>
+          </a:xfrm>
+          <a:prstGeom prst="ellipse">
+            <a:avLst/>
+          </a:prstGeom>
+          <a:solidFill>
+            <a:srgbClr val="262AFF"/>
+          </a:solidFill>
+          <a:ln/>
+        </p:spPr>
+      </p:sp>
+      <p:sp>
+        <p:nvSpPr>
+          <p:cNvPr id="70" name="Text 62"/>
+          <p:cNvSpPr/>
+          <p:nvPr/>
+        </p:nvSpPr>
+        <p:spPr>
+          <a:xfrm>
+            <a:off x="8313725" y="5138928"/>
+            <a:ext cx="310896" cy="310896"/>
+          </a:xfrm>
+          <a:prstGeom prst="rect">
+            <a:avLst/>
+          </a:prstGeom>
+          <a:noFill/>
+          <a:ln/>
+        </p:spPr>
+        <p:txBody>
+          <a:bodyPr wrap="square" lIns="0" tIns="0" rIns="0" bIns="0" rtlCol="0" anchor="ctr"/>
+          <a:lstStyle/>
+          <a:p>
+            <a:pPr algn="ctr" indent="0" marL="0">
+              <a:buNone/>
+            </a:pPr>
+            <a:r>
+              <a:rPr lang="en-US" sz="1200" b="1" dirty="0">
+                <a:solidFill>
+                  <a:srgbClr val="FFFFFF"/>
+                </a:solidFill>
+                <a:latin typeface="DM Sans" pitchFamily="34" charset="0"/>
+                <a:ea typeface="DM Sans" pitchFamily="34" charset="-122"/>
+                <a:cs typeface="DM Sans" pitchFamily="34" charset="-120"/>
+              </a:rPr>
+              <a:t>3</a:t>
+            </a:r>
+            <a:endParaRPr lang="en-US" sz="1200" dirty="0"/>
+          </a:p>
+        </p:txBody>
+      </p:sp>
+      <p:sp>
+        <p:nvSpPr>
+          <p:cNvPr id="71" name="Text 63"/>
+          <p:cNvSpPr/>
+          <p:nvPr/>
+        </p:nvSpPr>
+        <p:spPr>
+          <a:xfrm>
+            <a:off x="8752637" y="5056632"/>
+            <a:ext cx="2716682" cy="548640"/>
+          </a:xfrm>
+          <a:prstGeom prst="rect">
+            <a:avLst/>
+          </a:prstGeom>
+          <a:noFill/>
+          <a:ln/>
+        </p:spPr>
+        <p:txBody>
+          <a:bodyPr wrap="square" lIns="0" tIns="0" rIns="0" bIns="0" rtlCol="0" anchor="ctr"/>
+          <a:lstStyle/>
+          <a:p>
+            <a:pPr indent="0" marL="0">
+              <a:buNone/>
+            </a:pPr>
+            <a:r>
+              <a:rPr lang="en-US" sz="1100" b="1" dirty="0">
+                <a:solidFill>
+                  <a:srgbClr val="0C0C0C"/>
+                </a:solidFill>
+                <a:latin typeface="DM Sans" pitchFamily="34" charset="0"/>
+                <a:ea typeface="DM Sans" pitchFamily="34" charset="-122"/>
+                <a:cs typeface="DM Sans" pitchFamily="34" charset="-120"/>
+              </a:rPr>
+              <a:t>Return with the full plan</a:t>
+            </a:r>
+            <a:endParaRPr lang="en-US" sz="1100" dirty="0"/>
+          </a:p>
+          <a:p>
+            <a:pPr indent="0" marL="0">
+              <a:buNone/>
+            </a:pPr>
+            <a:r>
+              <a:rPr lang="en-US" sz="950" dirty="0">
+                <a:solidFill>
+                  <a:srgbClr val="55565B"/>
+                </a:solidFill>
+                <a:latin typeface="DM Sans" pitchFamily="34" charset="0"/>
+                <a:ea typeface="DM Sans" pitchFamily="34" charset="-122"/>
+                <a:cs typeface="DM Sans" pitchFamily="34" charset="-120"/>
+              </a:rPr>
+              <a:t>to Technology Committee &amp; Board</a:t>
+            </a:r>
+            <a:endParaRPr lang="en-US" sz="1100" dirty="0"/>
+          </a:p>
+        </p:txBody>
+      </p:sp>
+      <p:sp>
+        <p:nvSpPr>
+          <p:cNvPr id="72" name="Shape 64"/>
           <p:cNvSpPr/>
           <p:nvPr/>
         </p:nvSpPr>
@@ -2859,7 +3531,7 @@
       </p:sp>
       <p:sp>
         <p:nvSpPr>
-          <p:cNvPr id="54" name="Text 46"/>
+          <p:cNvPr id="73" name="Text 65"/>
           <p:cNvSpPr/>
           <p:nvPr/>
         </p:nvSpPr>
@@ -2898,7 +3570,7 @@
       </p:sp>
       <p:sp>
         <p:nvSpPr>
-          <p:cNvPr id="55" name="Text 47"/>
+          <p:cNvPr id="74" name="Text 66"/>
           <p:cNvSpPr/>
           <p:nvPr/>
         </p:nvSpPr>
@@ -2929,7 +3601,7 @@
                 <a:ea typeface="DM Sans" pitchFamily="34" charset="-122"/>
                 <a:cs typeface="DM Sans" pitchFamily="34" charset="-120"/>
               </a:rPr>
-              <a:t>1. Share of total technology capex    2. Technology capital only; excludes merchant incentives, impairments, and revenue effects</a:t>
+              <a:t>1. Share of total technology capex    2. Across GP25 &amp; Helix    3. Technology capital only; excludes merchant incentives, impairments, and revenue effects</a:t>
             </a:r>
             <a:endParaRPr lang="en-US" sz="750" dirty="0"/>
           </a:p>
@@ -2937,7 +3609,7 @@
       </p:sp>
       <p:pic>
         <p:nvPicPr>
-          <p:cNvPr id="56" name="Image 6" descr="unpacked/ppt/media/image2.png">    </p:cNvPr>
+          <p:cNvPr id="75" name="Image 6" descr="unpacked/ppt/media/image2.png">    </p:cNvPr>
           <p:cNvPicPr>
             <a:picLocks noChangeAspect="1"/>
           </p:cNvPicPr>
@@ -2961,7 +3633,7 @@
       </p:pic>
       <p:sp>
         <p:nvSpPr>
-          <p:cNvPr id="57" name="Text 48"/>
+          <p:cNvPr id="76" name="Text 67"/>
           <p:cNvSpPr/>
           <p:nvPr/>
         </p:nvSpPr>
@@ -3000,7 +3672,7 @@
       </p:sp>
       <p:sp>
         <p:nvSpPr>
-          <p:cNvPr id="58" name="Text 49"/>
+          <p:cNvPr id="77" name="Text 68"/>
           <p:cNvSpPr/>
           <p:nvPr/>
         </p:nvSpPr>
@@ -5321,7 +5993,7 @@
         <p:spPr>
           <a:xfrm>
             <a:off x="8778240" y="1143000"/>
-            <a:ext cx="2956255" cy="274320"/>
+            <a:ext cx="2956255" cy="256032"/>
           </a:xfrm>
           <a:prstGeom prst="rect">
             <a:avLst/>
@@ -5337,7 +6009,7 @@
               <a:buNone/>
             </a:pPr>
             <a:r>
-              <a:rPr lang="en-US" sz="1100" b="1" spc="200" kern="0" dirty="0">
+              <a:rPr lang="en-US" sz="1050" b="1" spc="200" kern="0" dirty="0">
                 <a:solidFill>
                   <a:srgbClr val="262AFF"/>
                 </a:solidFill>
@@ -5347,7 +6019,7 @@
               </a:rPr>
               <a:t>WHAT IT UNLOCKS</a:t>
             </a:r>
-            <a:endParaRPr lang="en-US" sz="1100" dirty="0"/>
+            <a:endParaRPr lang="en-US" sz="1050" dirty="0"/>
           </a:p>
         </p:txBody>
       </p:sp>
@@ -5498,7 +6170,7 @@
               <a:buNone/>
             </a:pPr>
             <a:r>
-              <a:rPr lang="en-US" sz="2600" b="1" dirty="0">
+              <a:rPr lang="en-US" sz="3200" b="1" dirty="0">
                 <a:solidFill>
                   <a:srgbClr val="262AFF"/>
                 </a:solidFill>
@@ -5506,9 +6178,9 @@
                 <a:ea typeface="DM Sans" pitchFamily="34" charset="-122"/>
                 <a:cs typeface="DM Sans" pitchFamily="34" charset="-120"/>
               </a:rPr>
-              <a:t>~10% → ~8%</a:t>
-            </a:r>
-            <a:endParaRPr lang="en-US" sz="2600" dirty="0"/>
+              <a:t>$200M+</a:t>
+            </a:r>
+            <a:endParaRPr lang="en-US" sz="3200" dirty="0"/>
           </a:p>
         </p:txBody>
       </p:sp>
@@ -5545,7 +6217,7 @@
                 <a:ea typeface="DM Sans" pitchFamily="34" charset="-122"/>
                 <a:cs typeface="DM Sans" pitchFamily="34" charset="-120"/>
               </a:rPr>
-              <a:t>technology spend as a share of revenue</a:t>
+              <a:t>operating expense unlock over 5 years — committed</a:t>
             </a:r>
             <a:endParaRPr lang="en-US" sz="1050" dirty="0"/>
           </a:p>
@@ -5598,7 +6270,7 @@
               <a:buNone/>
             </a:pPr>
             <a:r>
-              <a:rPr lang="en-US" sz="3200" b="1" dirty="0">
+              <a:rPr lang="en-US" sz="2200" b="1" dirty="0">
                 <a:solidFill>
                   <a:srgbClr val="262AFF"/>
                 </a:solidFill>
@@ -5606,9 +6278,9 @@
                 <a:ea typeface="DM Sans" pitchFamily="34" charset="-122"/>
                 <a:cs typeface="DM Sans" pitchFamily="34" charset="-120"/>
               </a:rPr>
-              <a:t>$200M+</a:t>
-            </a:r>
-            <a:endParaRPr lang="en-US" sz="3200" dirty="0"/>
+              <a:t>KTLO → growth</a:t>
+            </a:r>
+            <a:endParaRPr lang="en-US" sz="2200" dirty="0"/>
           </a:p>
         </p:txBody>
       </p:sp>
@@ -5645,7 +6317,7 @@
                 <a:ea typeface="DM Sans" pitchFamily="34" charset="-122"/>
                 <a:cs typeface="DM Sans" pitchFamily="34" charset="-120"/>
               </a:rPr>
-              <a:t>operating expense unlock over 5 years — committed</a:t>
+              <a:t>capital refocused from maintenance to strategic development</a:t>
             </a:r>
             <a:endParaRPr lang="en-US" sz="1050" dirty="0"/>
           </a:p>

</xml_diff>

<commit_message>
Rework 'what we did' box around decision rubric and stakeholders
The third top-row box now mirrors the Board deck's decision-approach
page: the four evaluation criteria as chips (strategic fit, commercial
performance, capability coverage, technical foundations) with the
SME-recommend / functions-shape / leads-validate line beneath.

Co-Authored-By: Claude Fable 5 <noreply@anthropic.com>
Claude-Session: https://claude.ai/code/session_01EWFJ2qXeCLrhhc9JV2HxT2
</commit_message>
<xml_diff>
--- a/TAM_2.0_Tech_Committee_2pager.pptx
+++ b/TAM_2.0_Tech_Committee_2pager.pptx
@@ -503,7 +503,7 @@
           <a:p>
             <a:r>
               <a:rPr lang="en-US" dirty="0"/>
-              <a:t>One-page executive summary of the July 2026 TAM 2.0 Board update, prepared for the Technology Committee. Reads as a 3x2 grid: the problem (fragmented estate, capex locked in KTLO), why now (customer expectations, perception gap, synergy commitments), what we did (GP25 &amp; Helix results, target state decided), the plan (&gt;80% estate reduction in two phases), the return ($200M+ committed opex unlock; enter/win/retain), and what's next (sequencing, cost to achieve, execution-ready plan back to Technology Committee &amp; Board).</a:t>
+              <a:t>One-page executive summary of the July 2026 TAM 2.0 Board update, prepared for the Technology Committee. Reads as a 3x2 grid: the problem (fragmented estate, capex locked in KTLO), why now (customer expectations, perception gap, synergy commitments), what we did (one rubric — strategic fit, commercial performance, capability coverage, technical foundations — with SME recommendation, functional input, and leadership validation), the plan (&gt;80% estate reduction in two phases), the return ($200M+ committed opex unlock; enter/win/retain), and what's next (sequencing, cost to achieve, execution-ready plan back to Technology Committee &amp; Board).</a:t>
             </a:r>
             <a:endParaRPr lang="en-US" dirty="0"/>
           </a:p>
@@ -1926,7 +1926,7 @@
                 <a:ea typeface="DM Sans" pitchFamily="34" charset="-122"/>
                 <a:cs typeface="DM Sans" pitchFamily="34" charset="-120"/>
               </a:rPr>
-              <a:t>THE MODEL IS ALREADY PROVEN</a:t>
+              <a:t>ONE RUBRIC, EVERY PLATFORM</a:t>
             </a:r>
             <a:endParaRPr lang="en-US" sz="1050" dirty="0"/>
           </a:p>
@@ -1934,30 +1934,52 @@
       </p:sp>
       <p:sp>
         <p:nvSpPr>
-          <p:cNvPr id="29" name="Text 24"/>
-          <p:cNvSpPr/>
-          <p:nvPr/>
-        </p:nvSpPr>
-        <p:spPr>
-          <a:xfrm>
-            <a:off x="8313725" y="1417320"/>
-            <a:ext cx="1536192" cy="365760"/>
-          </a:xfrm>
-          <a:prstGeom prst="rect">
-            <a:avLst/>
-          </a:prstGeom>
-          <a:noFill/>
-          <a:ln/>
-        </p:spPr>
-        <p:txBody>
-          <a:bodyPr wrap="square" lIns="0" tIns="0" rIns="0" bIns="0" rtlCol="0" anchor="ctr"/>
-          <a:lstStyle/>
-          <a:p>
-            <a:pPr indent="0" marL="0">
-              <a:buNone/>
-            </a:pPr>
-            <a:r>
-              <a:rPr lang="en-US" sz="2200" b="1" dirty="0">
+          <p:cNvPr id="29" name="Shape 24"/>
+          <p:cNvSpPr/>
+          <p:nvPr/>
+        </p:nvSpPr>
+        <p:spPr>
+          <a:xfrm>
+            <a:off x="8313725" y="1426464"/>
+            <a:ext cx="1517904" cy="548640"/>
+          </a:xfrm>
+          <a:prstGeom prst="roundRect">
+            <a:avLst>
+              <a:gd name="adj" fmla="val 8333"/>
+            </a:avLst>
+          </a:prstGeom>
+          <a:solidFill>
+            <a:srgbClr val="FFFFFF"/>
+          </a:solidFill>
+          <a:ln/>
+        </p:spPr>
+      </p:sp>
+      <p:sp>
+        <p:nvSpPr>
+          <p:cNvPr id="30" name="Text 25"/>
+          <p:cNvSpPr/>
+          <p:nvPr/>
+        </p:nvSpPr>
+        <p:spPr>
+          <a:xfrm>
+            <a:off x="8386877" y="1426464"/>
+            <a:ext cx="1371600" cy="548640"/>
+          </a:xfrm>
+          <a:prstGeom prst="rect">
+            <a:avLst/>
+          </a:prstGeom>
+          <a:noFill/>
+          <a:ln/>
+        </p:spPr>
+        <p:txBody>
+          <a:bodyPr wrap="square" lIns="0" tIns="0" rIns="0" bIns="0" rtlCol="0" anchor="ctr"/>
+          <a:lstStyle/>
+          <a:p>
+            <a:pPr algn="ctr" indent="0" marL="0">
+              <a:buNone/>
+            </a:pPr>
+            <a:r>
+              <a:rPr lang="en-US" sz="1050" b="1" dirty="0">
                 <a:solidFill>
                   <a:srgbClr val="0C0C0C"/>
                 </a:solidFill>
@@ -1965,77 +1987,60 @@
                 <a:ea typeface="DM Sans" pitchFamily="34" charset="-122"/>
                 <a:cs typeface="DM Sans" pitchFamily="34" charset="-120"/>
               </a:rPr>
-              <a:t>60+</a:t>
-            </a:r>
-            <a:endParaRPr lang="en-US" sz="2200" dirty="0"/>
-          </a:p>
-        </p:txBody>
-      </p:sp>
-      <p:sp>
-        <p:nvSpPr>
-          <p:cNvPr id="30" name="Text 25"/>
-          <p:cNvSpPr/>
-          <p:nvPr/>
-        </p:nvSpPr>
-        <p:spPr>
-          <a:xfrm>
-            <a:off x="8313725" y="1764792"/>
-            <a:ext cx="1536192" cy="201168"/>
-          </a:xfrm>
-          <a:prstGeom prst="rect">
-            <a:avLst/>
-          </a:prstGeom>
-          <a:noFill/>
-          <a:ln/>
-        </p:spPr>
-        <p:txBody>
-          <a:bodyPr wrap="square" lIns="0" tIns="0" rIns="0" bIns="0" rtlCol="0" anchor="ctr"/>
-          <a:lstStyle/>
-          <a:p>
-            <a:pPr indent="0" marL="0">
-              <a:buNone/>
-            </a:pPr>
-            <a:r>
-              <a:rPr lang="en-US" sz="900" dirty="0">
-                <a:solidFill>
-                  <a:srgbClr val="55565B"/>
-                </a:solidFill>
-                <a:latin typeface="DM Sans" pitchFamily="34" charset="0"/>
-                <a:ea typeface="DM Sans" pitchFamily="34" charset="-122"/>
-                <a:cs typeface="DM Sans" pitchFamily="34" charset="-120"/>
-              </a:rPr>
-              <a:t>platforms retired²</a:t>
-            </a:r>
-            <a:endParaRPr lang="en-US" sz="900" dirty="0"/>
-          </a:p>
-        </p:txBody>
-      </p:sp>
-      <p:sp>
-        <p:nvSpPr>
-          <p:cNvPr id="31" name="Text 26"/>
-          <p:cNvSpPr/>
-          <p:nvPr/>
-        </p:nvSpPr>
-        <p:spPr>
-          <a:xfrm>
-            <a:off x="9941357" y="1417320"/>
-            <a:ext cx="1536192" cy="365760"/>
-          </a:xfrm>
-          <a:prstGeom prst="rect">
-            <a:avLst/>
-          </a:prstGeom>
-          <a:noFill/>
-          <a:ln/>
-        </p:spPr>
-        <p:txBody>
-          <a:bodyPr wrap="square" lIns="0" tIns="0" rIns="0" bIns="0" rtlCol="0" anchor="ctr"/>
-          <a:lstStyle/>
-          <a:p>
-            <a:pPr indent="0" marL="0">
-              <a:buNone/>
-            </a:pPr>
-            <a:r>
-              <a:rPr lang="en-US" sz="2200" b="1" dirty="0">
+              <a:t>Strategic fit</a:t>
+            </a:r>
+            <a:endParaRPr lang="en-US" sz="1050" dirty="0"/>
+          </a:p>
+        </p:txBody>
+      </p:sp>
+      <p:sp>
+        <p:nvSpPr>
+          <p:cNvPr id="31" name="Shape 26"/>
+          <p:cNvSpPr/>
+          <p:nvPr/>
+        </p:nvSpPr>
+        <p:spPr>
+          <a:xfrm>
+            <a:off x="9950501" y="1426464"/>
+            <a:ext cx="1517904" cy="548640"/>
+          </a:xfrm>
+          <a:prstGeom prst="roundRect">
+            <a:avLst>
+              <a:gd name="adj" fmla="val 8333"/>
+            </a:avLst>
+          </a:prstGeom>
+          <a:solidFill>
+            <a:srgbClr val="FFFFFF"/>
+          </a:solidFill>
+          <a:ln/>
+        </p:spPr>
+      </p:sp>
+      <p:sp>
+        <p:nvSpPr>
+          <p:cNvPr id="32" name="Text 27"/>
+          <p:cNvSpPr/>
+          <p:nvPr/>
+        </p:nvSpPr>
+        <p:spPr>
+          <a:xfrm>
+            <a:off x="10023653" y="1426464"/>
+            <a:ext cx="1371600" cy="548640"/>
+          </a:xfrm>
+          <a:prstGeom prst="rect">
+            <a:avLst/>
+          </a:prstGeom>
+          <a:noFill/>
+          <a:ln/>
+        </p:spPr>
+        <p:txBody>
+          <a:bodyPr wrap="square" lIns="0" tIns="0" rIns="0" bIns="0" rtlCol="0" anchor="ctr"/>
+          <a:lstStyle/>
+          <a:p>
+            <a:pPr algn="ctr" indent="0" marL="0">
+              <a:buNone/>
+            </a:pPr>
+            <a:r>
+              <a:rPr lang="en-US" sz="1050" b="1" dirty="0">
                 <a:solidFill>
                   <a:srgbClr val="0C0C0C"/>
                 </a:solidFill>
@@ -2043,77 +2048,60 @@
                 <a:ea typeface="DM Sans" pitchFamily="34" charset="-122"/>
                 <a:cs typeface="DM Sans" pitchFamily="34" charset="-120"/>
               </a:rPr>
-              <a:t>180K+</a:t>
-            </a:r>
-            <a:endParaRPr lang="en-US" sz="2200" dirty="0"/>
-          </a:p>
-        </p:txBody>
-      </p:sp>
-      <p:sp>
-        <p:nvSpPr>
-          <p:cNvPr id="32" name="Text 27"/>
-          <p:cNvSpPr/>
-          <p:nvPr/>
-        </p:nvSpPr>
-        <p:spPr>
-          <a:xfrm>
-            <a:off x="9941357" y="1764792"/>
-            <a:ext cx="1536192" cy="201168"/>
-          </a:xfrm>
-          <a:prstGeom prst="rect">
-            <a:avLst/>
-          </a:prstGeom>
-          <a:noFill/>
-          <a:ln/>
-        </p:spPr>
-        <p:txBody>
-          <a:bodyPr wrap="square" lIns="0" tIns="0" rIns="0" bIns="0" rtlCol="0" anchor="ctr"/>
-          <a:lstStyle/>
-          <a:p>
-            <a:pPr indent="0" marL="0">
-              <a:buNone/>
-            </a:pPr>
-            <a:r>
-              <a:rPr lang="en-US" sz="900" dirty="0">
-                <a:solidFill>
-                  <a:srgbClr val="55565B"/>
-                </a:solidFill>
-                <a:latin typeface="DM Sans" pitchFamily="34" charset="0"/>
-                <a:ea typeface="DM Sans" pitchFamily="34" charset="-122"/>
-                <a:cs typeface="DM Sans" pitchFamily="34" charset="-120"/>
-              </a:rPr>
-              <a:t>merchants on one portal</a:t>
-            </a:r>
-            <a:endParaRPr lang="en-US" sz="900" dirty="0"/>
-          </a:p>
-        </p:txBody>
-      </p:sp>
-      <p:sp>
-        <p:nvSpPr>
-          <p:cNvPr id="33" name="Text 28"/>
-          <p:cNvSpPr/>
-          <p:nvPr/>
-        </p:nvSpPr>
-        <p:spPr>
-          <a:xfrm>
-            <a:off x="8313725" y="2112264"/>
-            <a:ext cx="1536192" cy="365760"/>
-          </a:xfrm>
-          <a:prstGeom prst="rect">
-            <a:avLst/>
-          </a:prstGeom>
-          <a:noFill/>
-          <a:ln/>
-        </p:spPr>
-        <p:txBody>
-          <a:bodyPr wrap="square" lIns="0" tIns="0" rIns="0" bIns="0" rtlCol="0" anchor="ctr"/>
-          <a:lstStyle/>
-          <a:p>
-            <a:pPr indent="0" marL="0">
-              <a:buNone/>
-            </a:pPr>
-            <a:r>
-              <a:rPr lang="en-US" sz="2200" b="1" dirty="0">
+              <a:t>Commercial performance</a:t>
+            </a:r>
+            <a:endParaRPr lang="en-US" sz="1050" dirty="0"/>
+          </a:p>
+        </p:txBody>
+      </p:sp>
+      <p:sp>
+        <p:nvSpPr>
+          <p:cNvPr id="33" name="Shape 28"/>
+          <p:cNvSpPr/>
+          <p:nvPr/>
+        </p:nvSpPr>
+        <p:spPr>
+          <a:xfrm>
+            <a:off x="8313725" y="2084832"/>
+            <a:ext cx="1517904" cy="548640"/>
+          </a:xfrm>
+          <a:prstGeom prst="roundRect">
+            <a:avLst>
+              <a:gd name="adj" fmla="val 8333"/>
+            </a:avLst>
+          </a:prstGeom>
+          <a:solidFill>
+            <a:srgbClr val="FFFFFF"/>
+          </a:solidFill>
+          <a:ln/>
+        </p:spPr>
+      </p:sp>
+      <p:sp>
+        <p:nvSpPr>
+          <p:cNvPr id="34" name="Text 29"/>
+          <p:cNvSpPr/>
+          <p:nvPr/>
+        </p:nvSpPr>
+        <p:spPr>
+          <a:xfrm>
+            <a:off x="8386877" y="2084832"/>
+            <a:ext cx="1371600" cy="548640"/>
+          </a:xfrm>
+          <a:prstGeom prst="rect">
+            <a:avLst/>
+          </a:prstGeom>
+          <a:noFill/>
+          <a:ln/>
+        </p:spPr>
+        <p:txBody>
+          <a:bodyPr wrap="square" lIns="0" tIns="0" rIns="0" bIns="0" rtlCol="0" anchor="ctr"/>
+          <a:lstStyle/>
+          <a:p>
+            <a:pPr algn="ctr" indent="0" marL="0">
+              <a:buNone/>
+            </a:pPr>
+            <a:r>
+              <a:rPr lang="en-US" sz="1050" b="1" dirty="0">
                 <a:solidFill>
                   <a:srgbClr val="0C0C0C"/>
                 </a:solidFill>
@@ -2121,77 +2109,60 @@
                 <a:ea typeface="DM Sans" pitchFamily="34" charset="-122"/>
                 <a:cs typeface="DM Sans" pitchFamily="34" charset="-120"/>
               </a:rPr>
-              <a:t>–60%</a:t>
-            </a:r>
-            <a:endParaRPr lang="en-US" sz="2200" dirty="0"/>
-          </a:p>
-        </p:txBody>
-      </p:sp>
-      <p:sp>
-        <p:nvSpPr>
-          <p:cNvPr id="34" name="Text 29"/>
-          <p:cNvSpPr/>
-          <p:nvPr/>
-        </p:nvSpPr>
-        <p:spPr>
-          <a:xfrm>
-            <a:off x="8313725" y="2459736"/>
-            <a:ext cx="1536192" cy="201168"/>
-          </a:xfrm>
-          <a:prstGeom prst="rect">
-            <a:avLst/>
-          </a:prstGeom>
-          <a:noFill/>
-          <a:ln/>
-        </p:spPr>
-        <p:txBody>
-          <a:bodyPr wrap="square" lIns="0" tIns="0" rIns="0" bIns="0" rtlCol="0" anchor="ctr"/>
-          <a:lstStyle/>
-          <a:p>
-            <a:pPr indent="0" marL="0">
-              <a:buNone/>
-            </a:pPr>
-            <a:r>
-              <a:rPr lang="en-US" sz="900" dirty="0">
-                <a:solidFill>
-                  <a:srgbClr val="55565B"/>
-                </a:solidFill>
-                <a:latin typeface="DM Sans" pitchFamily="34" charset="0"/>
-                <a:ea typeface="DM Sans" pitchFamily="34" charset="-122"/>
-                <a:cs typeface="DM Sans" pitchFamily="34" charset="-120"/>
-              </a:rPr>
-              <a:t>service calls, NPS +5</a:t>
-            </a:r>
-            <a:endParaRPr lang="en-US" sz="900" dirty="0"/>
-          </a:p>
-        </p:txBody>
-      </p:sp>
-      <p:sp>
-        <p:nvSpPr>
-          <p:cNvPr id="35" name="Text 30"/>
-          <p:cNvSpPr/>
-          <p:nvPr/>
-        </p:nvSpPr>
-        <p:spPr>
-          <a:xfrm>
-            <a:off x="9941357" y="2112264"/>
-            <a:ext cx="1536192" cy="365760"/>
-          </a:xfrm>
-          <a:prstGeom prst="rect">
-            <a:avLst/>
-          </a:prstGeom>
-          <a:noFill/>
-          <a:ln/>
-        </p:spPr>
-        <p:txBody>
-          <a:bodyPr wrap="square" lIns="0" tIns="0" rIns="0" bIns="0" rtlCol="0" anchor="ctr"/>
-          <a:lstStyle/>
-          <a:p>
-            <a:pPr indent="0" marL="0">
-              <a:buNone/>
-            </a:pPr>
-            <a:r>
-              <a:rPr lang="en-US" sz="2200" b="1" dirty="0">
+              <a:t>Capability coverage</a:t>
+            </a:r>
+            <a:endParaRPr lang="en-US" sz="1050" dirty="0"/>
+          </a:p>
+        </p:txBody>
+      </p:sp>
+      <p:sp>
+        <p:nvSpPr>
+          <p:cNvPr id="35" name="Shape 30"/>
+          <p:cNvSpPr/>
+          <p:nvPr/>
+        </p:nvSpPr>
+        <p:spPr>
+          <a:xfrm>
+            <a:off x="9950501" y="2084832"/>
+            <a:ext cx="1517904" cy="548640"/>
+          </a:xfrm>
+          <a:prstGeom prst="roundRect">
+            <a:avLst>
+              <a:gd name="adj" fmla="val 8333"/>
+            </a:avLst>
+          </a:prstGeom>
+          <a:solidFill>
+            <a:srgbClr val="FFFFFF"/>
+          </a:solidFill>
+          <a:ln/>
+        </p:spPr>
+      </p:sp>
+      <p:sp>
+        <p:nvSpPr>
+          <p:cNvPr id="36" name="Text 31"/>
+          <p:cNvSpPr/>
+          <p:nvPr/>
+        </p:nvSpPr>
+        <p:spPr>
+          <a:xfrm>
+            <a:off x="10023653" y="2084832"/>
+            <a:ext cx="1371600" cy="548640"/>
+          </a:xfrm>
+          <a:prstGeom prst="rect">
+            <a:avLst/>
+          </a:prstGeom>
+          <a:noFill/>
+          <a:ln/>
+        </p:spPr>
+        <p:txBody>
+          <a:bodyPr wrap="square" lIns="0" tIns="0" rIns="0" bIns="0" rtlCol="0" anchor="ctr"/>
+          <a:lstStyle/>
+          <a:p>
+            <a:pPr algn="ctr" indent="0" marL="0">
+              <a:buNone/>
+            </a:pPr>
+            <a:r>
+              <a:rPr lang="en-US" sz="1050" b="1" dirty="0">
                 <a:solidFill>
                   <a:srgbClr val="0C0C0C"/>
                 </a:solidFill>
@@ -2199,48 +2170,9 @@
                 <a:ea typeface="DM Sans" pitchFamily="34" charset="-122"/>
                 <a:cs typeface="DM Sans" pitchFamily="34" charset="-120"/>
               </a:rPr>
-              <a:t>13</a:t>
-            </a:r>
-            <a:endParaRPr lang="en-US" sz="2200" dirty="0"/>
-          </a:p>
-        </p:txBody>
-      </p:sp>
-      <p:sp>
-        <p:nvSpPr>
-          <p:cNvPr id="36" name="Text 31"/>
-          <p:cNvSpPr/>
-          <p:nvPr/>
-        </p:nvSpPr>
-        <p:spPr>
-          <a:xfrm>
-            <a:off x="9941357" y="2459736"/>
-            <a:ext cx="1536192" cy="201168"/>
-          </a:xfrm>
-          <a:prstGeom prst="rect">
-            <a:avLst/>
-          </a:prstGeom>
-          <a:noFill/>
-          <a:ln/>
-        </p:spPr>
-        <p:txBody>
-          <a:bodyPr wrap="square" lIns="0" tIns="0" rIns="0" bIns="0" rtlCol="0" anchor="ctr"/>
-          <a:lstStyle/>
-          <a:p>
-            <a:pPr indent="0" marL="0">
-              <a:buNone/>
-            </a:pPr>
-            <a:r>
-              <a:rPr lang="en-US" sz="900" dirty="0">
-                <a:solidFill>
-                  <a:srgbClr val="55565B"/>
-                </a:solidFill>
-                <a:latin typeface="DM Sans" pitchFamily="34" charset="0"/>
-                <a:ea typeface="DM Sans" pitchFamily="34" charset="-122"/>
-                <a:cs typeface="DM Sans" pitchFamily="34" charset="-120"/>
-              </a:rPr>
-              <a:t>days to first payment, UK</a:t>
-            </a:r>
-            <a:endParaRPr lang="en-US" sz="900" dirty="0"/>
+              <a:t>Technical foundations</a:t>
+            </a:r>
+            <a:endParaRPr lang="en-US" sz="1050" dirty="0"/>
           </a:p>
         </p:txBody>
       </p:sp>
@@ -2300,7 +2232,7 @@
                 <a:ea typeface="DM Sans" pitchFamily="34" charset="-122"/>
                 <a:cs typeface="DM Sans" pitchFamily="34" charset="-120"/>
               </a:rPr>
-              <a:t>Target state decided</a:t>
+              <a:t>SMEs recommend, functions shape, leads validate</a:t>
             </a:r>
             <a:pPr indent="0" marL="0">
               <a:buNone/>
@@ -2314,7 +2246,7 @@
                 <a:ea typeface="DM Sans" pitchFamily="34" charset="-122"/>
                 <a:cs typeface="DM Sans" pitchFamily="34" charset="-120"/>
               </a:rPr>
-              <a:t> &amp; validated across all functions</a:t>
+              <a:t> — Product, Eng., Architecture, Data &amp; Business</a:t>
             </a:r>
             <a:endParaRPr lang="en-US" sz="950" dirty="0"/>
           </a:p>
@@ -3386,7 +3318,7 @@
                 <a:ea typeface="DM Sans" pitchFamily="34" charset="-122"/>
                 <a:cs typeface="DM Sans" pitchFamily="34" charset="-120"/>
               </a:rPr>
-              <a:t>up to ~$500M³; ~$200–250M in Y1–2</a:t>
+              <a:t>up to ~$500M²; ~$200–250M in Y1–2</a:t>
             </a:r>
             <a:endParaRPr lang="en-US" sz="1100" dirty="0"/>
           </a:p>
@@ -3601,7 +3533,7 @@
                 <a:ea typeface="DM Sans" pitchFamily="34" charset="-122"/>
                 <a:cs typeface="DM Sans" pitchFamily="34" charset="-120"/>
               </a:rPr>
-              <a:t>1. Share of total technology capex    2. Across GP25 &amp; Helix    3. Technology capital only; excludes merchant incentives, impairments, and revenue effects</a:t>
+              <a:t>1. Share of total technology capex    2. Technology capital only; excludes merchant incentives, impairments, and revenue effects</a:t>
             </a:r>
             <a:endParaRPr lang="en-US" sz="750" dirty="0"/>
           </a:p>

</xml_diff>

<commit_message>
Replace quantified unlocks with qualitative tiles on from-to rail
Per direction, drop >80% and $200M+ from "what it unlocks"; rail now
reads Build once / One experience / KTLO -> growth.

Co-Authored-By: Claude Fable 5 <noreply@anthropic.com>
Claude-Session: https://claude.ai/code/session_01EWFJ2qXeCLrhhc9JV2HxT2
</commit_message>
<xml_diff>
--- a/TAM_2.0_Tech_Committee_2pager.pptx
+++ b/TAM_2.0_Tech_Committee_2pager.pptx
@@ -591,7 +591,7 @@
           <a:p>
             <a:r>
               <a:rPr lang="en-US" dirty="0"/>
-              <a:t>From-to view of the TAM 2.0 target state, drawn from the consolidation-impact pages of the July 2026 Board update. Left: platform counts by capability, today versus target. Right: what the consolidation unlocks — &gt;80% smaller estate, the committed $200M+ opex unlock, and capital refocused from KTLO to strategic development.</a:t>
+              <a:t>From-to view of the TAM 2.0 target state, drawn from the consolidation-impact pages of the July 2026 Board update. Left: platform counts by capability, today versus target. Right: what the consolidation unlocks — build once and deploy everywhere, one consistent customer experience, and capital refocused from KTLO to strategic development.</a:t>
             </a:r>
             <a:endParaRPr lang="en-US" dirty="0"/>
           </a:p>
@@ -6002,7 +6002,7 @@
               <a:buNone/>
             </a:pPr>
             <a:r>
-              <a:rPr lang="en-US" sz="4000" b="1" dirty="0">
+              <a:rPr lang="en-US" sz="2600" b="1" dirty="0">
                 <a:solidFill>
                   <a:srgbClr val="262AFF"/>
                 </a:solidFill>
@@ -6010,9 +6010,9 @@
                 <a:ea typeface="DM Sans" pitchFamily="34" charset="-122"/>
                 <a:cs typeface="DM Sans" pitchFamily="34" charset="-120"/>
               </a:rPr>
-              <a:t>&gt;80%</a:t>
-            </a:r>
-            <a:endParaRPr lang="en-US" sz="4000" dirty="0"/>
+              <a:t>Build once</a:t>
+            </a:r>
+            <a:endParaRPr lang="en-US" sz="2600" dirty="0"/>
           </a:p>
         </p:txBody>
       </p:sp>
@@ -6049,7 +6049,7 @@
                 <a:ea typeface="DM Sans" pitchFamily="34" charset="-122"/>
                 <a:cs typeface="DM Sans" pitchFamily="34" charset="-120"/>
               </a:rPr>
-              <a:t>smaller platform estate in the target state</a:t>
+              <a:t>deploy to every market &amp; segment — faster speed to market</a:t>
             </a:r>
             <a:endParaRPr lang="en-US" sz="1050" dirty="0"/>
           </a:p>
@@ -6102,7 +6102,7 @@
               <a:buNone/>
             </a:pPr>
             <a:r>
-              <a:rPr lang="en-US" sz="3200" b="1" dirty="0">
+              <a:rPr lang="en-US" sz="2400" b="1" dirty="0">
                 <a:solidFill>
                   <a:srgbClr val="262AFF"/>
                 </a:solidFill>
@@ -6110,9 +6110,9 @@
                 <a:ea typeface="DM Sans" pitchFamily="34" charset="-122"/>
                 <a:cs typeface="DM Sans" pitchFamily="34" charset="-120"/>
               </a:rPr>
-              <a:t>$200M+</a:t>
-            </a:r>
-            <a:endParaRPr lang="en-US" sz="3200" dirty="0"/>
+              <a:t>One experience</a:t>
+            </a:r>
+            <a:endParaRPr lang="en-US" sz="2400" dirty="0"/>
           </a:p>
         </p:txBody>
       </p:sp>
@@ -6149,7 +6149,7 @@
                 <a:ea typeface="DM Sans" pitchFamily="34" charset="-122"/>
                 <a:cs typeface="DM Sans" pitchFamily="34" charset="-120"/>
               </a:rPr>
-              <a:t>operating expense unlock over 5 years — committed</a:t>
+              <a:t>consistent boarding, billing &amp; support across segments &amp; geos</a:t>
             </a:r>
             <a:endParaRPr lang="en-US" sz="1050" dirty="0"/>
           </a:p>

</xml_diff>

<commit_message>
Anchor unlock-tile wording to on-slide deck language
Tile subtexts now assemble from main-deck slide text only (slides 3, 7,
and 8 of the Board deck), not speaker notes.

Co-Authored-By: Claude Fable 5 <noreply@anthropic.com>
Claude-Session: https://claude.ai/code/session_01EWFJ2qXeCLrhhc9JV2HxT2
</commit_message>
<xml_diff>
--- a/TAM_2.0_Tech_Committee_2pager.pptx
+++ b/TAM_2.0_Tech_Committee_2pager.pptx
@@ -6049,7 +6049,7 @@
                 <a:ea typeface="DM Sans" pitchFamily="34" charset="-122"/>
                 <a:cs typeface="DM Sans" pitchFamily="34" charset="-120"/>
               </a:rPr>
-              <a:t>deploy to every market &amp; segment — faster speed to market</a:t>
+              <a:t>same platforms across all geographies — faster speed to market</a:t>
             </a:r>
             <a:endParaRPr lang="en-US" sz="1050" dirty="0"/>
           </a:p>
@@ -6149,7 +6149,7 @@
                 <a:ea typeface="DM Sans" pitchFamily="34" charset="-122"/>
                 <a:cs typeface="DM Sans" pitchFamily="34" charset="-120"/>
               </a:rPr>
-              <a:t>consistent boarding, billing &amp; support across segments &amp; geos</a:t>
+              <a:t>one signup, consistent support, one place to manage the business</a:t>
             </a:r>
             <a:endParaRPr lang="en-US" sz="1050" dirty="0"/>
           </a:p>
@@ -6249,7 +6249,7 @@
                 <a:ea typeface="DM Sans" pitchFamily="34" charset="-122"/>
                 <a:cs typeface="DM Sans" pitchFamily="34" charset="-120"/>
               </a:rPr>
-              <a:t>capital refocused from maintenance to strategic development</a:t>
+              <a:t>resources refocused from KTLO to strategic development</a:t>
             </a:r>
             <a:endParaRPr lang="en-US" sz="1050" dirty="0"/>
           </a:p>

</xml_diff>

<commit_message>
Fix problem-box causality; set from-to rail to state-shift tiles
Problem card: the bottom line now carries the causal claim (~45% of
tech capex locked in KTLO -> can't self-fund), the ~10%-of-revenue line
is dropped, and 35 data centers joins the sprawl stats. From-to rail:
Fragmented->seamless / Complexity->advantage / KTLO->growth, all from
main-deck slide language.

Co-Authored-By: Claude Fable 5 <noreply@anthropic.com>
Claude-Session: https://claude.ai/code/session_01EWFJ2qXeCLrhhc9JV2HxT2
</commit_message>
<xml_diff>
--- a/TAM_2.0_Tech_Committee_2pager.pptx
+++ b/TAM_2.0_Tech_Committee_2pager.pptx
@@ -591,7 +591,7 @@
           <a:p>
             <a:r>
               <a:rPr lang="en-US" dirty="0"/>
-              <a:t>From-to view of the TAM 2.0 target state, drawn from the consolidation-impact pages of the July 2026 Board update. Left: platform counts by capability, today versus target. Right: what the consolidation unlocks — build once and deploy everywhere, one consistent customer experience, and capital refocused from KTLO to strategic development.</a:t>
+              <a:t>From-to view of the TAM 2.0 target state, drawn from the consolidation-impact pages of the July 2026 Board update. Left: platform counts by capability, today versus target. Right: what the consolidation unlocks — a fragmented estate becoming one seamless experience, scale converted into competitive advantage, and resources refocused from KTLO to strategic development.</a:t>
             </a:r>
             <a:endParaRPr lang="en-US" dirty="0"/>
           </a:p>
@@ -1384,7 +1384,7 @@
                 <a:ea typeface="DM Sans" pitchFamily="34" charset="-122"/>
                 <a:cs typeface="DM Sans" pitchFamily="34" charset="-120"/>
               </a:rPr>
-              <a:t>~45%</a:t>
+              <a:t>35</a:t>
             </a:r>
             <a:endParaRPr lang="en-US" sz="2200" dirty="0"/>
           </a:p>
@@ -1423,7 +1423,7 @@
                 <a:ea typeface="DM Sans" pitchFamily="34" charset="-122"/>
                 <a:cs typeface="DM Sans" pitchFamily="34" charset="-120"/>
               </a:rPr>
-              <a:t>of tech capex in KTLO¹</a:t>
+              <a:t>data centers</a:t>
             </a:r>
             <a:endParaRPr lang="en-US" sz="900" dirty="0"/>
           </a:p>
@@ -1477,20 +1477,6 @@
               <a:buNone/>
             </a:pPr>
             <a:r>
-              <a:rPr lang="en-US" sz="950" dirty="0">
-                <a:solidFill>
-                  <a:srgbClr val="55565B"/>
-                </a:solidFill>
-                <a:latin typeface="DM Sans" pitchFamily="34" charset="0"/>
-                <a:ea typeface="DM Sans" pitchFamily="34" charset="-122"/>
-                <a:cs typeface="DM Sans" pitchFamily="34" charset="-120"/>
-              </a:rPr>
-              <a:t>Tech spend </a:t>
-            </a:r>
-            <a:pPr indent="0" marL="0">
-              <a:buNone/>
-            </a:pPr>
-            <a:r>
               <a:rPr lang="en-US" sz="950" b="1" dirty="0">
                 <a:solidFill>
                   <a:srgbClr val="0C0C0C"/>
@@ -1499,7 +1485,7 @@
                 <a:ea typeface="DM Sans" pitchFamily="34" charset="-122"/>
                 <a:cs typeface="DM Sans" pitchFamily="34" charset="-120"/>
               </a:rPr>
-              <a:t>~10% of revenue</a:t>
+              <a:t>~45% of tech capex locked in KTLO¹</a:t>
             </a:r>
             <a:pPr indent="0" marL="0">
               <a:buNone/>
@@ -6002,7 +5988,7 @@
               <a:buNone/>
             </a:pPr>
             <a:r>
-              <a:rPr lang="en-US" sz="2600" b="1" dirty="0">
+              <a:rPr lang="en-US" sz="2000" b="1" dirty="0">
                 <a:solidFill>
                   <a:srgbClr val="262AFF"/>
                 </a:solidFill>
@@ -6010,9 +5996,9 @@
                 <a:ea typeface="DM Sans" pitchFamily="34" charset="-122"/>
                 <a:cs typeface="DM Sans" pitchFamily="34" charset="-120"/>
               </a:rPr>
-              <a:t>Build once</a:t>
-            </a:r>
-            <a:endParaRPr lang="en-US" sz="2600" dirty="0"/>
+              <a:t>Fragmented → seamless</a:t>
+            </a:r>
+            <a:endParaRPr lang="en-US" sz="2000" dirty="0"/>
           </a:p>
         </p:txBody>
       </p:sp>
@@ -6049,7 +6035,7 @@
                 <a:ea typeface="DM Sans" pitchFamily="34" charset="-122"/>
                 <a:cs typeface="DM Sans" pitchFamily="34" charset="-120"/>
               </a:rPr>
-              <a:t>same platforms across all geographies — faster speed to market</a:t>
+              <a:t>one seamless experience across channels and the payments journey</a:t>
             </a:r>
             <a:endParaRPr lang="en-US" sz="1050" dirty="0"/>
           </a:p>
@@ -6102,7 +6088,7 @@
               <a:buNone/>
             </a:pPr>
             <a:r>
-              <a:rPr lang="en-US" sz="2400" b="1" dirty="0">
+              <a:rPr lang="en-US" sz="2000" b="1" dirty="0">
                 <a:solidFill>
                   <a:srgbClr val="262AFF"/>
                 </a:solidFill>
@@ -6110,9 +6096,9 @@
                 <a:ea typeface="DM Sans" pitchFamily="34" charset="-122"/>
                 <a:cs typeface="DM Sans" pitchFamily="34" charset="-120"/>
               </a:rPr>
-              <a:t>One experience</a:t>
-            </a:r>
-            <a:endParaRPr lang="en-US" sz="2400" dirty="0"/>
+              <a:t>Complexity → advantage</a:t>
+            </a:r>
+            <a:endParaRPr lang="en-US" sz="2000" dirty="0"/>
           </a:p>
         </p:txBody>
       </p:sp>
@@ -6149,7 +6135,7 @@
                 <a:ea typeface="DM Sans" pitchFamily="34" charset="-122"/>
                 <a:cs typeface="DM Sans" pitchFamily="34" charset="-120"/>
               </a:rPr>
-              <a:t>one signup, consistent support, one place to manage the business</a:t>
+              <a:t>scale converted into our decisive competitive advantage</a:t>
             </a:r>
             <a:endParaRPr lang="en-US" sz="1050" dirty="0"/>
           </a:p>
@@ -6202,7 +6188,7 @@
               <a:buNone/>
             </a:pPr>
             <a:r>
-              <a:rPr lang="en-US" sz="2200" b="1" dirty="0">
+              <a:rPr lang="en-US" sz="2000" b="1" dirty="0">
                 <a:solidFill>
                   <a:srgbClr val="262AFF"/>
                 </a:solidFill>
@@ -6212,7 +6198,7 @@
               </a:rPr>
               <a:t>KTLO → growth</a:t>
             </a:r>
-            <a:endParaRPr lang="en-US" sz="2200" dirty="0"/>
+            <a:endParaRPr lang="en-US" sz="2000" dirty="0"/>
           </a:p>
         </p:txBody>
       </p:sp>

</xml_diff>